<commit_message>
feat: Introduce numerous LINE Bot with Gemini Colab examples covering various functionalities, alongside development references, and update the README.
</commit_message>
<xml_diff>
--- a/Slides/05. 基礎觀念及知識.pptx
+++ b/Slides/05. 基礎觀念及知識.pptx
@@ -6,7 +6,7 @@
     <p:sldMasterId id="2147483660" r:id="rId2"/>
   </p:sldMasterIdLst>
   <p:notesMasterIdLst>
-    <p:notesMasterId r:id="rId47"/>
+    <p:notesMasterId r:id="rId46"/>
   </p:notesMasterIdLst>
   <p:sldIdLst>
     <p:sldId id="681" r:id="rId3"/>
@@ -44,15 +44,14 @@
     <p:sldId id="898" r:id="rId35"/>
     <p:sldId id="1387" r:id="rId36"/>
     <p:sldId id="1393" r:id="rId37"/>
-    <p:sldId id="1394" r:id="rId38"/>
-    <p:sldId id="1395" r:id="rId39"/>
-    <p:sldId id="1396" r:id="rId40"/>
-    <p:sldId id="1397" r:id="rId41"/>
-    <p:sldId id="1398" r:id="rId42"/>
-    <p:sldId id="1399" r:id="rId43"/>
-    <p:sldId id="1400" r:id="rId44"/>
-    <p:sldId id="1401" r:id="rId45"/>
-    <p:sldId id="1402" r:id="rId46"/>
+    <p:sldId id="1395" r:id="rId38"/>
+    <p:sldId id="1396" r:id="rId39"/>
+    <p:sldId id="1397" r:id="rId40"/>
+    <p:sldId id="1398" r:id="rId41"/>
+    <p:sldId id="1399" r:id="rId42"/>
+    <p:sldId id="1400" r:id="rId43"/>
+    <p:sldId id="1401" r:id="rId44"/>
+    <p:sldId id="1402" r:id="rId45"/>
   </p:sldIdLst>
   <p:sldSz cx="9144000" cy="6858000" type="screen4x3"/>
   <p:notesSz cx="6858000" cy="9144000"/>
@@ -241,7 +240,7 @@
           <a:p>
             <a:fld id="{90CC8E63-1016-4C78-A51D-85D69DBCD8EF}" type="datetimeFigureOut">
               <a:rPr lang="zh-TW" altLang="en-US" smtClean="0"/>
-              <a:t>2026/3/26</a:t>
+              <a:t>2026/4/16</a:t>
             </a:fld>
             <a:endParaRPr lang="zh-TW" altLang="en-US"/>
           </a:p>
@@ -2655,7 +2654,7 @@
     </p:spTree>
     <p:extLst>
       <p:ext uri="{BB962C8B-B14F-4D97-AF65-F5344CB8AC3E}">
-        <p14:creationId xmlns:p14="http://schemas.microsoft.com/office/powerpoint/2010/main" val="486184695"/>
+        <p14:creationId xmlns:p14="http://schemas.microsoft.com/office/powerpoint/2010/main" val="704296369"/>
       </p:ext>
     </p:extLst>
   </p:cSld>
@@ -2740,7 +2739,7 @@
     </p:spTree>
     <p:extLst>
       <p:ext uri="{BB962C8B-B14F-4D97-AF65-F5344CB8AC3E}">
-        <p14:creationId xmlns:p14="http://schemas.microsoft.com/office/powerpoint/2010/main" val="704296369"/>
+        <p14:creationId xmlns:p14="http://schemas.microsoft.com/office/powerpoint/2010/main" val="480796205"/>
       </p:ext>
     </p:extLst>
   </p:cSld>
@@ -2825,7 +2824,7 @@
     </p:spTree>
     <p:extLst>
       <p:ext uri="{BB962C8B-B14F-4D97-AF65-F5344CB8AC3E}">
-        <p14:creationId xmlns:p14="http://schemas.microsoft.com/office/powerpoint/2010/main" val="480796205"/>
+        <p14:creationId xmlns:p14="http://schemas.microsoft.com/office/powerpoint/2010/main" val="1777473766"/>
       </p:ext>
     </p:extLst>
   </p:cSld>
@@ -2910,7 +2909,7 @@
     </p:spTree>
     <p:extLst>
       <p:ext uri="{BB962C8B-B14F-4D97-AF65-F5344CB8AC3E}">
-        <p14:creationId xmlns:p14="http://schemas.microsoft.com/office/powerpoint/2010/main" val="1777473766"/>
+        <p14:creationId xmlns:p14="http://schemas.microsoft.com/office/powerpoint/2010/main" val="1237604203"/>
       </p:ext>
     </p:extLst>
   </p:cSld>
@@ -2987,91 +2986,6 @@
               <a:rPr lang="en-US" smtClean="0"/>
               <a:pPr/>
               <a:t>40</a:t>
-            </a:fld>
-            <a:endParaRPr lang="en-US" dirty="0"/>
-          </a:p>
-        </p:txBody>
-      </p:sp>
-    </p:spTree>
-    <p:extLst>
-      <p:ext uri="{BB962C8B-B14F-4D97-AF65-F5344CB8AC3E}">
-        <p14:creationId xmlns:p14="http://schemas.microsoft.com/office/powerpoint/2010/main" val="1237604203"/>
-      </p:ext>
-    </p:extLst>
-  </p:cSld>
-  <p:clrMapOvr>
-    <a:masterClrMapping/>
-  </p:clrMapOvr>
-</p:notes>
-</file>
-
-<file path=ppt/notesSlides/notesSlide29.xml><?xml version="1.0" encoding="utf-8"?>
-<p:notes xmlns:a="http://schemas.openxmlformats.org/drawingml/2006/main" xmlns:r="http://schemas.openxmlformats.org/officeDocument/2006/relationships" xmlns:p="http://schemas.openxmlformats.org/presentationml/2006/main">
-  <p:cSld>
-    <p:spTree>
-      <p:nvGrpSpPr>
-        <p:cNvPr id="1" name=""/>
-        <p:cNvGrpSpPr/>
-        <p:nvPr/>
-      </p:nvGrpSpPr>
-      <p:grpSpPr>
-        <a:xfrm>
-          <a:off x="0" y="0"/>
-          <a:ext cx="0" cy="0"/>
-          <a:chOff x="0" y="0"/>
-          <a:chExt cx="0" cy="0"/>
-        </a:xfrm>
-      </p:grpSpPr>
-      <p:sp>
-        <p:nvSpPr>
-          <p:cNvPr id="2" name="投影片圖像版面配置區 1"/>
-          <p:cNvSpPr>
-            <a:spLocks noGrp="1" noRot="1" noChangeAspect="1"/>
-          </p:cNvSpPr>
-          <p:nvPr>
-            <p:ph type="sldImg"/>
-          </p:nvPr>
-        </p:nvSpPr>
-        <p:spPr/>
-      </p:sp>
-      <p:sp>
-        <p:nvSpPr>
-          <p:cNvPr id="3" name="備忘稿版面配置區 2"/>
-          <p:cNvSpPr>
-            <a:spLocks noGrp="1"/>
-          </p:cNvSpPr>
-          <p:nvPr>
-            <p:ph type="body" idx="1"/>
-          </p:nvPr>
-        </p:nvSpPr>
-        <p:spPr/>
-        <p:txBody>
-          <a:bodyPr/>
-          <a:lstStyle/>
-          <a:p>
-            <a:endParaRPr lang="zh-TW" altLang="en-US" dirty="0"/>
-          </a:p>
-        </p:txBody>
-      </p:sp>
-      <p:sp>
-        <p:nvSpPr>
-          <p:cNvPr id="4" name="投影片編號版面配置區 3"/>
-          <p:cNvSpPr>
-            <a:spLocks noGrp="1"/>
-          </p:cNvSpPr>
-          <p:nvPr>
-            <p:ph type="sldNum" sz="quarter" idx="10"/>
-          </p:nvPr>
-        </p:nvSpPr>
-        <p:spPr/>
-        <p:txBody>
-          <a:bodyPr/>
-          <a:lstStyle/>
-          <a:p>
-            <a:fld id="{9B26CD33-4337-4529-948A-94F6960B2374}" type="slidenum">
-              <a:rPr lang="en-US" smtClean="0"/>
-              <a:pPr/>
-              <a:t>41</a:t>
             </a:fld>
             <a:endParaRPr lang="en-US" dirty="0"/>
           </a:p>
@@ -4282,7 +4196,7 @@
           <a:p>
             <a:fld id="{2E29796B-F55F-40BA-947E-19D03180300F}" type="datetimeFigureOut">
               <a:rPr lang="zh-TW" altLang="en-US" smtClean="0"/>
-              <a:t>2026/3/26</a:t>
+              <a:t>2026/4/16</a:t>
             </a:fld>
             <a:endParaRPr lang="zh-TW" altLang="en-US"/>
           </a:p>
@@ -4480,7 +4394,7 @@
           <a:p>
             <a:fld id="{2E29796B-F55F-40BA-947E-19D03180300F}" type="datetimeFigureOut">
               <a:rPr lang="zh-TW" altLang="en-US" smtClean="0"/>
-              <a:t>2026/3/26</a:t>
+              <a:t>2026/4/16</a:t>
             </a:fld>
             <a:endParaRPr lang="zh-TW" altLang="en-US"/>
           </a:p>
@@ -4688,7 +4602,7 @@
           <a:p>
             <a:fld id="{2E29796B-F55F-40BA-947E-19D03180300F}" type="datetimeFigureOut">
               <a:rPr lang="zh-TW" altLang="en-US" smtClean="0"/>
-              <a:t>2026/3/26</a:t>
+              <a:t>2026/4/16</a:t>
             </a:fld>
             <a:endParaRPr lang="zh-TW" altLang="en-US"/>
           </a:p>
@@ -5069,7 +4983,7 @@
                 </a:solidFill>
               </a:rPr>
               <a:pPr/>
-              <a:t>3/26/2026</a:t>
+              <a:t>4/16/2026</a:t>
             </a:fld>
             <a:endParaRPr kumimoji="0" lang="en-US" dirty="0"/>
           </a:p>
@@ -5300,7 +5214,7 @@
                 </a:solidFill>
               </a:rPr>
               <a:pPr/>
-              <a:t>3/26/2026</a:t>
+              <a:t>4/16/2026</a:t>
             </a:fld>
             <a:endParaRPr kumimoji="0" lang="en-US" dirty="0"/>
           </a:p>
@@ -5533,7 +5447,7 @@
                 </a:solidFill>
               </a:rPr>
               <a:pPr/>
-              <a:t>3/26/2026</a:t>
+              <a:t>4/16/2026</a:t>
             </a:fld>
             <a:endParaRPr kumimoji="0" lang="en-US" dirty="0"/>
           </a:p>
@@ -6015,7 +5929,7 @@
                 </a:solidFill>
               </a:rPr>
               <a:pPr/>
-              <a:t>3/26/2026</a:t>
+              <a:t>4/16/2026</a:t>
             </a:fld>
             <a:endParaRPr kumimoji="0" lang="en-US" dirty="0"/>
           </a:p>
@@ -6372,7 +6286,7 @@
                 </a:solidFill>
               </a:rPr>
               <a:pPr/>
-              <a:t>3/26/2026</a:t>
+              <a:t>4/16/2026</a:t>
             </a:fld>
             <a:endParaRPr kumimoji="0" lang="en-US" dirty="0"/>
           </a:p>
@@ -6735,7 +6649,7 @@
                 </a:solidFill>
               </a:rPr>
               <a:pPr/>
-              <a:t>3/26/2026</a:t>
+              <a:t>4/16/2026</a:t>
             </a:fld>
             <a:endParaRPr kumimoji="0" lang="en-US" dirty="0"/>
           </a:p>
@@ -7045,7 +6959,7 @@
                 </a:solidFill>
               </a:rPr>
               <a:pPr/>
-              <a:t>3/26/2026</a:t>
+              <a:t>4/16/2026</a:t>
             </a:fld>
             <a:endParaRPr kumimoji="0" lang="en-US" dirty="0"/>
           </a:p>
@@ -7240,7 +7154,7 @@
           <a:p>
             <a:fld id="{2E29796B-F55F-40BA-947E-19D03180300F}" type="datetimeFigureOut">
               <a:rPr lang="zh-TW" altLang="en-US" smtClean="0"/>
-              <a:t>2026/3/26</a:t>
+              <a:t>2026/4/16</a:t>
             </a:fld>
             <a:endParaRPr lang="zh-TW" altLang="en-US"/>
           </a:p>
@@ -7724,7 +7638,7 @@
                 </a:solidFill>
               </a:rPr>
               <a:pPr/>
-              <a:t>3/26/2026</a:t>
+              <a:t>4/16/2026</a:t>
             </a:fld>
             <a:endParaRPr kumimoji="0" lang="en-US" dirty="0"/>
           </a:p>
@@ -8120,7 +8034,7 @@
                 </a:solidFill>
               </a:rPr>
               <a:pPr/>
-              <a:t>3/26/2026</a:t>
+              <a:t>4/16/2026</a:t>
             </a:fld>
             <a:endParaRPr kumimoji="0" lang="en-US" dirty="0"/>
           </a:p>
@@ -8460,7 +8374,7 @@
                 </a:solidFill>
               </a:rPr>
               <a:pPr/>
-              <a:t>3/26/2026</a:t>
+              <a:t>4/16/2026</a:t>
             </a:fld>
             <a:endParaRPr kumimoji="0" lang="en-US" dirty="0"/>
           </a:p>
@@ -9041,7 +8955,7 @@
                 </a:solidFill>
               </a:rPr>
               <a:pPr/>
-              <a:t>3/26/2026</a:t>
+              <a:t>4/16/2026</a:t>
             </a:fld>
             <a:endParaRPr kumimoji="0" lang="en-US" dirty="0"/>
           </a:p>
@@ -9610,7 +9524,7 @@
                 </a:solidFill>
               </a:rPr>
               <a:pPr/>
-              <a:t>3/26/2026</a:t>
+              <a:t>4/16/2026</a:t>
             </a:fld>
             <a:endParaRPr kumimoji="0" lang="en-US" dirty="0"/>
           </a:p>
@@ -10074,7 +9988,7 @@
                 </a:solidFill>
               </a:rPr>
               <a:pPr/>
-              <a:t>3/26/2026</a:t>
+              <a:t>4/16/2026</a:t>
             </a:fld>
             <a:endParaRPr kumimoji="0" lang="en-US" dirty="0"/>
           </a:p>
@@ -10503,7 +10417,7 @@
                 </a:solidFill>
               </a:rPr>
               <a:pPr/>
-              <a:t>3/26/2026</a:t>
+              <a:t>4/16/2026</a:t>
             </a:fld>
             <a:endParaRPr kumimoji="0" lang="en-US" dirty="0"/>
           </a:p>
@@ -11012,7 +10926,7 @@
                 </a:solidFill>
               </a:rPr>
               <a:pPr/>
-              <a:t>3/26/2026</a:t>
+              <a:t>4/16/2026</a:t>
             </a:fld>
             <a:endParaRPr kumimoji="0" lang="en-US" dirty="0"/>
           </a:p>
@@ -11521,7 +11435,7 @@
                 </a:solidFill>
               </a:rPr>
               <a:pPr/>
-              <a:t>3/26/2026</a:t>
+              <a:t>4/16/2026</a:t>
             </a:fld>
             <a:endParaRPr kumimoji="0" lang="en-US" dirty="0"/>
           </a:p>
@@ -11742,7 +11656,7 @@
                 </a:solidFill>
               </a:rPr>
               <a:pPr/>
-              <a:t>3/26/2026</a:t>
+              <a:t>4/16/2026</a:t>
             </a:fld>
             <a:endParaRPr kumimoji="0" lang="en-US" dirty="0"/>
           </a:p>
@@ -12014,7 +11928,7 @@
           <a:p>
             <a:fld id="{2E29796B-F55F-40BA-947E-19D03180300F}" type="datetimeFigureOut">
               <a:rPr lang="zh-TW" altLang="en-US" smtClean="0"/>
-              <a:t>2026/3/26</a:t>
+              <a:t>2026/4/16</a:t>
             </a:fld>
             <a:endParaRPr lang="zh-TW" altLang="en-US"/>
           </a:p>
@@ -12350,7 +12264,7 @@
                 </a:solidFill>
               </a:rPr>
               <a:pPr/>
-              <a:t>3/26/2026</a:t>
+              <a:t>4/16/2026</a:t>
             </a:fld>
             <a:endParaRPr kumimoji="0" lang="en-US" dirty="0"/>
           </a:p>
@@ -12574,7 +12488,7 @@
                 </a:solidFill>
               </a:rPr>
               <a:pPr/>
-              <a:t>3/26/2026</a:t>
+              <a:t>4/16/2026</a:t>
             </a:fld>
             <a:endParaRPr kumimoji="0" lang="en-US" dirty="0"/>
           </a:p>
@@ -12755,7 +12669,7 @@
             <a:fld id="{ACB2EC6F-6501-4E04-BD6C-A8A6CABB2C5B}" type="datetimeFigureOut">
               <a:rPr kumimoji="0" lang="en-US" smtClean="0"/>
               <a:pPr/>
-              <a:t>3/26/2026</a:t>
+              <a:t>4/16/2026</a:t>
             </a:fld>
             <a:endParaRPr kumimoji="0" lang="en-US" dirty="0"/>
           </a:p>
@@ -13039,7 +12953,7 @@
           <a:p>
             <a:fld id="{2E29796B-F55F-40BA-947E-19D03180300F}" type="datetimeFigureOut">
               <a:rPr lang="zh-TW" altLang="en-US" smtClean="0"/>
-              <a:t>2026/3/26</a:t>
+              <a:t>2026/4/16</a:t>
             </a:fld>
             <a:endParaRPr lang="zh-TW" altLang="en-US"/>
           </a:p>
@@ -13451,7 +13365,7 @@
           <a:p>
             <a:fld id="{2E29796B-F55F-40BA-947E-19D03180300F}" type="datetimeFigureOut">
               <a:rPr lang="zh-TW" altLang="en-US" smtClean="0"/>
-              <a:t>2026/3/26</a:t>
+              <a:t>2026/4/16</a:t>
             </a:fld>
             <a:endParaRPr lang="zh-TW" altLang="en-US"/>
           </a:p>
@@ -13592,7 +13506,7 @@
           <a:p>
             <a:fld id="{2E29796B-F55F-40BA-947E-19D03180300F}" type="datetimeFigureOut">
               <a:rPr lang="zh-TW" altLang="en-US" smtClean="0"/>
-              <a:t>2026/3/26</a:t>
+              <a:t>2026/4/16</a:t>
             </a:fld>
             <a:endParaRPr lang="zh-TW" altLang="en-US"/>
           </a:p>
@@ -13705,7 +13619,7 @@
           <a:p>
             <a:fld id="{2E29796B-F55F-40BA-947E-19D03180300F}" type="datetimeFigureOut">
               <a:rPr lang="zh-TW" altLang="en-US" smtClean="0"/>
-              <a:t>2026/3/26</a:t>
+              <a:t>2026/4/16</a:t>
             </a:fld>
             <a:endParaRPr lang="zh-TW" altLang="en-US"/>
           </a:p>
@@ -14016,7 +13930,7 @@
           <a:p>
             <a:fld id="{2E29796B-F55F-40BA-947E-19D03180300F}" type="datetimeFigureOut">
               <a:rPr lang="zh-TW" altLang="en-US" smtClean="0"/>
-              <a:t>2026/3/26</a:t>
+              <a:t>2026/4/16</a:t>
             </a:fld>
             <a:endParaRPr lang="zh-TW" altLang="en-US"/>
           </a:p>
@@ -14304,7 +14218,7 @@
           <a:p>
             <a:fld id="{2E29796B-F55F-40BA-947E-19D03180300F}" type="datetimeFigureOut">
               <a:rPr lang="zh-TW" altLang="en-US" smtClean="0"/>
-              <a:t>2026/3/26</a:t>
+              <a:t>2026/4/16</a:t>
             </a:fld>
             <a:endParaRPr lang="zh-TW" altLang="en-US"/>
           </a:p>
@@ -14545,7 +14459,7 @@
           <a:p>
             <a:fld id="{2E29796B-F55F-40BA-947E-19D03180300F}" type="datetimeFigureOut">
               <a:rPr lang="zh-TW" altLang="en-US" smtClean="0"/>
-              <a:t>2026/3/26</a:t>
+              <a:t>2026/4/16</a:t>
             </a:fld>
             <a:endParaRPr lang="zh-TW" altLang="en-US"/>
           </a:p>
@@ -15117,7 +15031,7 @@
                 </a:solidFill>
               </a:rPr>
               <a:pPr/>
-              <a:t>3/26/2026</a:t>
+              <a:t>4/16/2026</a:t>
             </a:fld>
             <a:endParaRPr kumimoji="0" lang="en-US" sz="1200" dirty="0">
               <a:solidFill>
@@ -18076,7 +17990,7 @@
                   <a:schemeClr val="tx2"/>
                 </a:solidFill>
               </a:rPr>
-              <a:t>3/26/2026</a:t>
+              <a:t>4/16/2026</a:t>
             </a:fld>
             <a:endParaRPr kumimoji="0" lang="en-US" dirty="0"/>
           </a:p>
@@ -18268,7 +18182,7 @@
                 <a:latin typeface="Arial" panose="020B0604020202020204" pitchFamily="34" charset="0"/>
                 <a:cs typeface="Arial" panose="020B0604020202020204" pitchFamily="34" charset="0"/>
               </a:rPr>
-              <a:t>3/26/2026</a:t>
+              <a:t>4/16/2026</a:t>
             </a:fld>
             <a:endParaRPr kumimoji="0" lang="en-US" dirty="0">
               <a:latin typeface="Arial" panose="020B0604020202020204" pitchFamily="34" charset="0"/>
@@ -18831,7 +18745,7 @@
                 <a:latin typeface="Arial" panose="020B0604020202020204" pitchFamily="34" charset="0"/>
                 <a:cs typeface="Arial" panose="020B0604020202020204" pitchFamily="34" charset="0"/>
               </a:rPr>
-              <a:t>3/26/2026</a:t>
+              <a:t>4/16/2026</a:t>
             </a:fld>
             <a:endParaRPr kumimoji="0" lang="en-US" dirty="0">
               <a:latin typeface="Arial" panose="020B0604020202020204" pitchFamily="34" charset="0"/>
@@ -19489,7 +19403,7 @@
                 <a:latin typeface="Arial" panose="020B0604020202020204" pitchFamily="34" charset="0"/>
                 <a:cs typeface="Arial" panose="020B0604020202020204" pitchFamily="34" charset="0"/>
               </a:rPr>
-              <a:t>3/26/2026</a:t>
+              <a:t>4/16/2026</a:t>
             </a:fld>
             <a:endParaRPr kumimoji="0" lang="en-US" dirty="0">
               <a:latin typeface="Arial" panose="020B0604020202020204" pitchFamily="34" charset="0"/>
@@ -20829,7 +20743,7 @@
                 <a:latin typeface="Arial" panose="020B0604020202020204" pitchFamily="34" charset="0"/>
                 <a:cs typeface="Arial" panose="020B0604020202020204" pitchFamily="34" charset="0"/>
               </a:rPr>
-              <a:t>3/26/2026</a:t>
+              <a:t>4/16/2026</a:t>
             </a:fld>
             <a:endParaRPr kumimoji="0" lang="en-US" dirty="0">
               <a:latin typeface="Arial" panose="020B0604020202020204" pitchFamily="34" charset="0"/>
@@ -21429,7 +21343,7 @@
                 <a:latin typeface="Arial" panose="020B0604020202020204" pitchFamily="34" charset="0"/>
                 <a:cs typeface="Arial" panose="020B0604020202020204" pitchFamily="34" charset="0"/>
               </a:rPr>
-              <a:t>3/26/2026</a:t>
+              <a:t>4/16/2026</a:t>
             </a:fld>
             <a:endParaRPr kumimoji="0" lang="en-US" dirty="0">
               <a:latin typeface="Arial" panose="020B0604020202020204" pitchFamily="34" charset="0"/>
@@ -21468,208 +21382,6 @@
               </a:rPr>
               <a:pPr algn="r"/>
               <a:t>36</a:t>
-            </a:fld>
-            <a:endParaRPr kumimoji="0" lang="en-US" dirty="0"/>
-          </a:p>
-        </p:txBody>
-      </p:sp>
-      <p:pic>
-        <p:nvPicPr>
-          <p:cNvPr id="6" name="圖片 5">
-            <a:extLst>
-              <a:ext uri="{FF2B5EF4-FFF2-40B4-BE49-F238E27FC236}">
-                <a16:creationId xmlns:a16="http://schemas.microsoft.com/office/drawing/2014/main" id="{93E9FE9E-D12E-D058-B880-864FF39A0AED}"/>
-              </a:ext>
-            </a:extLst>
-          </p:cNvPr>
-          <p:cNvPicPr>
-            <a:picLocks noChangeAspect="1"/>
-          </p:cNvPicPr>
-          <p:nvPr/>
-        </p:nvPicPr>
-        <p:blipFill>
-          <a:blip r:embed="rId3"/>
-          <a:stretch>
-            <a:fillRect/>
-          </a:stretch>
-        </p:blipFill>
-        <p:spPr>
-          <a:xfrm>
-            <a:off x="206298" y="1726261"/>
-            <a:ext cx="8937702" cy="3565841"/>
-          </a:xfrm>
-          <a:prstGeom prst="rect">
-            <a:avLst/>
-          </a:prstGeom>
-        </p:spPr>
-      </p:pic>
-    </p:spTree>
-    <p:extLst>
-      <p:ext uri="{BB962C8B-B14F-4D97-AF65-F5344CB8AC3E}">
-        <p14:creationId xmlns:p14="http://schemas.microsoft.com/office/powerpoint/2010/main" val="1974786045"/>
-      </p:ext>
-    </p:extLst>
-  </p:cSld>
-  <p:clrMapOvr>
-    <a:masterClrMapping/>
-  </p:clrMapOvr>
-  <p:transition>
-    <p:fade/>
-  </p:transition>
-</p:sld>
-</file>
-
-<file path=ppt/slides/slide37.xml><?xml version="1.0" encoding="utf-8"?>
-<p:sld xmlns:a="http://schemas.openxmlformats.org/drawingml/2006/main" xmlns:r="http://schemas.openxmlformats.org/officeDocument/2006/relationships" xmlns:p="http://schemas.openxmlformats.org/presentationml/2006/main">
-  <p:cSld>
-    <p:spTree>
-      <p:nvGrpSpPr>
-        <p:cNvPr id="1" name=""/>
-        <p:cNvGrpSpPr/>
-        <p:nvPr/>
-      </p:nvGrpSpPr>
-      <p:grpSpPr>
-        <a:xfrm>
-          <a:off x="0" y="0"/>
-          <a:ext cx="0" cy="0"/>
-          <a:chOff x="0" y="0"/>
-          <a:chExt cx="0" cy="0"/>
-        </a:xfrm>
-      </p:grpSpPr>
-      <p:sp>
-        <p:nvSpPr>
-          <p:cNvPr id="4" name="文字版面配置區 2"/>
-          <p:cNvSpPr txBox="1">
-            <a:spLocks/>
-          </p:cNvSpPr>
-          <p:nvPr/>
-        </p:nvSpPr>
-        <p:spPr>
-          <a:xfrm>
-            <a:off x="2362200" y="228600"/>
-            <a:ext cx="5867400" cy="990600"/>
-          </a:xfrm>
-          <a:prstGeom prst="rect">
-            <a:avLst/>
-          </a:prstGeom>
-        </p:spPr>
-        <p:txBody>
-          <a:bodyPr tIns="91440" bIns="91440" anchor="b" anchorCtr="0">
-            <a:noAutofit/>
-          </a:bodyPr>
-          <a:lstStyle/>
-          <a:p>
-            <a:pPr marL="0" marR="0" lvl="0" indent="0" algn="just" defTabSz="914400" rtl="0" eaLnBrk="1" fontAlgn="auto" latinLnBrk="0" hangingPunct="1">
-              <a:lnSpc>
-                <a:spcPct val="100000"/>
-              </a:lnSpc>
-              <a:spcBef>
-                <a:spcPct val="20000"/>
-              </a:spcBef>
-              <a:spcAft>
-                <a:spcPts val="0"/>
-              </a:spcAft>
-              <a:buClrTx/>
-              <a:buSzTx/>
-              <a:buFontTx/>
-              <a:buNone/>
-              <a:tabLst/>
-              <a:defRPr/>
-            </a:pPr>
-            <a:r>
-              <a:rPr kumimoji="0" lang="zh-TW" altLang="en-US" sz="4800" b="1" i="0" u="none" strike="noStrike" kern="0" cap="none" spc="0" normalizeH="0" baseline="0" noProof="0" dirty="0">
-                <a:ln>
-                  <a:noFill/>
-                </a:ln>
-                <a:solidFill>
-                  <a:srgbClr val="00B0F0"/>
-                </a:solidFill>
-                <a:effectLst>
-                  <a:outerShdw blurRad="38100" dist="38100" dir="2700000" algn="tl">
-                    <a:srgbClr val="000000">
-                      <a:alpha val="43137"/>
-                    </a:srgbClr>
-                  </a:outerShdw>
-                </a:effectLst>
-                <a:uLnTx/>
-                <a:uFillTx/>
-                <a:latin typeface="微軟正黑體" panose="020B0604030504040204" pitchFamily="34" charset="-120"/>
-                <a:ea typeface="微軟正黑體" panose="020B0604030504040204" pitchFamily="34" charset="-120"/>
-                <a:cs typeface="+mn-cs"/>
-              </a:rPr>
-              <a:t>前端和後端語言</a:t>
-            </a:r>
-          </a:p>
-        </p:txBody>
-      </p:sp>
-      <p:sp>
-        <p:nvSpPr>
-          <p:cNvPr id="3" name="日期版面配置區 2">
-            <a:extLst>
-              <a:ext uri="{FF2B5EF4-FFF2-40B4-BE49-F238E27FC236}">
-                <a16:creationId xmlns:a16="http://schemas.microsoft.com/office/drawing/2014/main" id="{1C536CB5-3C58-6CF1-767E-952B76F12DEE}"/>
-              </a:ext>
-            </a:extLst>
-          </p:cNvPr>
-          <p:cNvSpPr>
-            <a:spLocks noGrp="1"/>
-          </p:cNvSpPr>
-          <p:nvPr>
-            <p:ph type="dt" sz="half" idx="12"/>
-          </p:nvPr>
-        </p:nvSpPr>
-        <p:spPr/>
-        <p:txBody>
-          <a:bodyPr/>
-          <a:lstStyle/>
-          <a:p>
-            <a:fld id="{0B520B05-2240-4566-BE2A-9338980FE8EB}" type="datetime1">
-              <a:rPr kumimoji="0" lang="en-US" altLang="zh-TW" sz="1200" smtClean="0">
-                <a:solidFill>
-                  <a:schemeClr val="tx2"/>
-                </a:solidFill>
-                <a:latin typeface="Arial" panose="020B0604020202020204" pitchFamily="34" charset="0"/>
-                <a:cs typeface="Arial" panose="020B0604020202020204" pitchFamily="34" charset="0"/>
-              </a:rPr>
-              <a:t>3/26/2026</a:t>
-            </a:fld>
-            <a:endParaRPr kumimoji="0" lang="en-US" dirty="0">
-              <a:latin typeface="Arial" panose="020B0604020202020204" pitchFamily="34" charset="0"/>
-              <a:cs typeface="Arial" panose="020B0604020202020204" pitchFamily="34" charset="0"/>
-            </a:endParaRPr>
-          </a:p>
-        </p:txBody>
-      </p:sp>
-      <p:sp>
-        <p:nvSpPr>
-          <p:cNvPr id="7" name="投影片編號版面配置區 6">
-            <a:extLst>
-              <a:ext uri="{FF2B5EF4-FFF2-40B4-BE49-F238E27FC236}">
-                <a16:creationId xmlns:a16="http://schemas.microsoft.com/office/drawing/2014/main" id="{DA316F56-AF12-D872-611F-78AE7ACCBF93}"/>
-              </a:ext>
-            </a:extLst>
-          </p:cNvPr>
-          <p:cNvSpPr>
-            <a:spLocks noGrp="1"/>
-          </p:cNvSpPr>
-          <p:nvPr>
-            <p:ph type="sldNum" sz="quarter" idx="13"/>
-          </p:nvPr>
-        </p:nvSpPr>
-        <p:spPr/>
-        <p:txBody>
-          <a:bodyPr/>
-          <a:lstStyle/>
-          <a:p>
-            <a:pPr algn="r"/>
-            <a:fld id="{F99EC173-99AE-4773-AB25-02E469A13EAE}" type="slidenum">
-              <a:rPr kumimoji="0" lang="en-US" sz="1200" smtClean="0">
-                <a:solidFill>
-                  <a:schemeClr val="tx2"/>
-                </a:solidFill>
-              </a:rPr>
-              <a:pPr algn="r"/>
-              <a:t>37</a:t>
             </a:fld>
             <a:endParaRPr kumimoji="0" lang="en-US" dirty="0"/>
           </a:p>
@@ -21721,7 +21433,7 @@
 </p:sld>
 </file>
 
-<file path=ppt/slides/slide38.xml><?xml version="1.0" encoding="utf-8"?>
+<file path=ppt/slides/slide37.xml><?xml version="1.0" encoding="utf-8"?>
 <p:sld xmlns:a="http://schemas.openxmlformats.org/drawingml/2006/main" xmlns:r="http://schemas.openxmlformats.org/officeDocument/2006/relationships" xmlns:p="http://schemas.openxmlformats.org/presentationml/2006/main">
   <p:cSld>
     <p:spTree>
@@ -21833,7 +21545,7 @@
                 <a:latin typeface="Arial" panose="020B0604020202020204" pitchFamily="34" charset="0"/>
                 <a:cs typeface="Arial" panose="020B0604020202020204" pitchFamily="34" charset="0"/>
               </a:rPr>
-              <a:t>3/26/2026</a:t>
+              <a:t>4/16/2026</a:t>
             </a:fld>
             <a:endParaRPr kumimoji="0" lang="en-US" dirty="0">
               <a:latin typeface="Arial" panose="020B0604020202020204" pitchFamily="34" charset="0"/>
@@ -21871,7 +21583,7 @@
                 </a:solidFill>
               </a:rPr>
               <a:pPr algn="r"/>
-              <a:t>38</a:t>
+              <a:t>37</a:t>
             </a:fld>
             <a:endParaRPr kumimoji="0" lang="en-US" dirty="0"/>
           </a:p>
@@ -21923,6 +21635,399 @@
 </p:sld>
 </file>
 
+<file path=ppt/slides/slide38.xml><?xml version="1.0" encoding="utf-8"?>
+<p:sld xmlns:a="http://schemas.openxmlformats.org/drawingml/2006/main" xmlns:r="http://schemas.openxmlformats.org/officeDocument/2006/relationships" xmlns:p="http://schemas.openxmlformats.org/presentationml/2006/main">
+  <p:cSld>
+    <p:spTree>
+      <p:nvGrpSpPr>
+        <p:cNvPr id="1" name=""/>
+        <p:cNvGrpSpPr/>
+        <p:nvPr/>
+      </p:nvGrpSpPr>
+      <p:grpSpPr>
+        <a:xfrm>
+          <a:off x="0" y="0"/>
+          <a:ext cx="0" cy="0"/>
+          <a:chOff x="0" y="0"/>
+          <a:chExt cx="0" cy="0"/>
+        </a:xfrm>
+      </p:grpSpPr>
+      <p:sp>
+        <p:nvSpPr>
+          <p:cNvPr id="4" name="文字版面配置區 2"/>
+          <p:cNvSpPr txBox="1">
+            <a:spLocks/>
+          </p:cNvSpPr>
+          <p:nvPr/>
+        </p:nvSpPr>
+        <p:spPr>
+          <a:xfrm>
+            <a:off x="2362200" y="228600"/>
+            <a:ext cx="5867400" cy="990600"/>
+          </a:xfrm>
+          <a:prstGeom prst="rect">
+            <a:avLst/>
+          </a:prstGeom>
+        </p:spPr>
+        <p:txBody>
+          <a:bodyPr tIns="91440" bIns="91440" anchor="b" anchorCtr="0">
+            <a:noAutofit/>
+          </a:bodyPr>
+          <a:lstStyle/>
+          <a:p>
+            <a:pPr marL="0" marR="0" lvl="0" indent="0" algn="just" defTabSz="914400" rtl="0" eaLnBrk="1" fontAlgn="auto" latinLnBrk="0" hangingPunct="1">
+              <a:lnSpc>
+                <a:spcPct val="100000"/>
+              </a:lnSpc>
+              <a:spcBef>
+                <a:spcPct val="20000"/>
+              </a:spcBef>
+              <a:spcAft>
+                <a:spcPts val="0"/>
+              </a:spcAft>
+              <a:buClrTx/>
+              <a:buSzTx/>
+              <a:buFontTx/>
+              <a:buNone/>
+              <a:tabLst/>
+              <a:defRPr/>
+            </a:pPr>
+            <a:r>
+              <a:rPr kumimoji="0" lang="zh-TW" altLang="en-US" sz="4800" b="1" i="0" u="none" strike="noStrike" kern="0" cap="none" spc="0" normalizeH="0" baseline="0" noProof="0" dirty="0">
+                <a:ln>
+                  <a:noFill/>
+                </a:ln>
+                <a:solidFill>
+                  <a:srgbClr val="00B0F0"/>
+                </a:solidFill>
+                <a:effectLst>
+                  <a:outerShdw blurRad="38100" dist="38100" dir="2700000" algn="tl">
+                    <a:srgbClr val="000000">
+                      <a:alpha val="43137"/>
+                    </a:srgbClr>
+                  </a:outerShdw>
+                </a:effectLst>
+                <a:uLnTx/>
+                <a:uFillTx/>
+                <a:latin typeface="微軟正黑體" panose="020B0604030504040204" pitchFamily="34" charset="-120"/>
+                <a:ea typeface="微軟正黑體" panose="020B0604030504040204" pitchFamily="34" charset="-120"/>
+                <a:cs typeface="+mn-cs"/>
+              </a:rPr>
+              <a:t>前端和後端語言</a:t>
+            </a:r>
+          </a:p>
+        </p:txBody>
+      </p:sp>
+      <p:sp>
+        <p:nvSpPr>
+          <p:cNvPr id="3" name="日期版面配置區 2">
+            <a:extLst>
+              <a:ext uri="{FF2B5EF4-FFF2-40B4-BE49-F238E27FC236}">
+                <a16:creationId xmlns:a16="http://schemas.microsoft.com/office/drawing/2014/main" id="{1C536CB5-3C58-6CF1-767E-952B76F12DEE}"/>
+              </a:ext>
+            </a:extLst>
+          </p:cNvPr>
+          <p:cNvSpPr>
+            <a:spLocks noGrp="1"/>
+          </p:cNvSpPr>
+          <p:nvPr>
+            <p:ph type="dt" sz="half" idx="12"/>
+          </p:nvPr>
+        </p:nvSpPr>
+        <p:spPr/>
+        <p:txBody>
+          <a:bodyPr/>
+          <a:lstStyle/>
+          <a:p>
+            <a:fld id="{0B520B05-2240-4566-BE2A-9338980FE8EB}" type="datetime1">
+              <a:rPr kumimoji="0" lang="en-US" altLang="zh-TW" sz="1200" smtClean="0">
+                <a:solidFill>
+                  <a:schemeClr val="tx2"/>
+                </a:solidFill>
+                <a:latin typeface="Arial" panose="020B0604020202020204" pitchFamily="34" charset="0"/>
+                <a:cs typeface="Arial" panose="020B0604020202020204" pitchFamily="34" charset="0"/>
+              </a:rPr>
+              <a:t>4/16/2026</a:t>
+            </a:fld>
+            <a:endParaRPr kumimoji="0" lang="en-US" dirty="0">
+              <a:latin typeface="Arial" panose="020B0604020202020204" pitchFamily="34" charset="0"/>
+              <a:cs typeface="Arial" panose="020B0604020202020204" pitchFamily="34" charset="0"/>
+            </a:endParaRPr>
+          </a:p>
+        </p:txBody>
+      </p:sp>
+      <p:sp>
+        <p:nvSpPr>
+          <p:cNvPr id="7" name="投影片編號版面配置區 6">
+            <a:extLst>
+              <a:ext uri="{FF2B5EF4-FFF2-40B4-BE49-F238E27FC236}">
+                <a16:creationId xmlns:a16="http://schemas.microsoft.com/office/drawing/2014/main" id="{DA316F56-AF12-D872-611F-78AE7ACCBF93}"/>
+              </a:ext>
+            </a:extLst>
+          </p:cNvPr>
+          <p:cNvSpPr>
+            <a:spLocks noGrp="1"/>
+          </p:cNvSpPr>
+          <p:nvPr>
+            <p:ph type="sldNum" sz="quarter" idx="13"/>
+          </p:nvPr>
+        </p:nvSpPr>
+        <p:spPr/>
+        <p:txBody>
+          <a:bodyPr/>
+          <a:lstStyle/>
+          <a:p>
+            <a:pPr algn="r"/>
+            <a:fld id="{F99EC173-99AE-4773-AB25-02E469A13EAE}" type="slidenum">
+              <a:rPr kumimoji="0" lang="en-US" sz="1200" smtClean="0">
+                <a:solidFill>
+                  <a:schemeClr val="tx2"/>
+                </a:solidFill>
+              </a:rPr>
+              <a:pPr algn="r"/>
+              <a:t>38</a:t>
+            </a:fld>
+            <a:endParaRPr kumimoji="0" lang="en-US" dirty="0"/>
+          </a:p>
+        </p:txBody>
+      </p:sp>
+      <p:sp>
+        <p:nvSpPr>
+          <p:cNvPr id="2" name="文字方塊 1">
+            <a:extLst>
+              <a:ext uri="{FF2B5EF4-FFF2-40B4-BE49-F238E27FC236}">
+                <a16:creationId xmlns:a16="http://schemas.microsoft.com/office/drawing/2014/main" id="{54D51629-6478-40B0-266D-C39EAC81C327}"/>
+              </a:ext>
+            </a:extLst>
+          </p:cNvPr>
+          <p:cNvSpPr txBox="1"/>
+          <p:nvPr/>
+        </p:nvSpPr>
+        <p:spPr>
+          <a:xfrm>
+            <a:off x="533400" y="1447800"/>
+            <a:ext cx="8305800" cy="4031873"/>
+          </a:xfrm>
+          <a:prstGeom prst="rect">
+            <a:avLst/>
+          </a:prstGeom>
+          <a:noFill/>
+        </p:spPr>
+        <p:txBody>
+          <a:bodyPr wrap="square" rtlCol="0">
+            <a:spAutoFit/>
+          </a:bodyPr>
+          <a:lstStyle/>
+          <a:p>
+            <a:pPr marL="358775" indent="-358775">
+              <a:buFont typeface="Arial" panose="020B0604020202020204" pitchFamily="34" charset="0"/>
+              <a:buChar char="•"/>
+            </a:pPr>
+            <a:r>
+              <a:rPr kumimoji="1" lang="zh-TW" altLang="en-US" sz="3200" dirty="0">
+                <a:effectLst>
+                  <a:outerShdw blurRad="38100" dist="38100" dir="2700000" algn="tl">
+                    <a:srgbClr val="000000">
+                      <a:alpha val="43137"/>
+                    </a:srgbClr>
+                  </a:outerShdw>
+                </a:effectLst>
+                <a:latin typeface="微軟正黑體" panose="020B0604030504040204" pitchFamily="34" charset="-120"/>
+                <a:ea typeface="微軟正黑體" panose="020B0604030504040204" pitchFamily="34" charset="-120"/>
+                <a:cs typeface="Heiti TC Light"/>
+              </a:rPr>
+              <a:t>使用者在瀏覽器中填寫的資料</a:t>
+            </a:r>
+            <a:r>
+              <a:rPr kumimoji="1" lang="en-US" altLang="zh-TW" sz="3200" dirty="0">
+                <a:effectLst>
+                  <a:outerShdw blurRad="38100" dist="38100" dir="2700000" algn="tl">
+                    <a:srgbClr val="000000">
+                      <a:alpha val="43137"/>
+                    </a:srgbClr>
+                  </a:outerShdw>
+                </a:effectLst>
+                <a:latin typeface="微軟正黑體" panose="020B0604030504040204" pitchFamily="34" charset="-120"/>
+                <a:ea typeface="微軟正黑體" panose="020B0604030504040204" pitchFamily="34" charset="-120"/>
+                <a:cs typeface="Heiti TC Light"/>
+              </a:rPr>
+              <a:t>(</a:t>
+            </a:r>
+            <a:r>
+              <a:rPr kumimoji="1" lang="zh-TW" altLang="en-US" sz="3200" dirty="0">
+                <a:effectLst>
+                  <a:outerShdw blurRad="38100" dist="38100" dir="2700000" algn="tl">
+                    <a:srgbClr val="000000">
+                      <a:alpha val="43137"/>
+                    </a:srgbClr>
+                  </a:outerShdw>
+                </a:effectLst>
+                <a:latin typeface="微軟正黑體" panose="020B0604030504040204" pitchFamily="34" charset="-120"/>
+                <a:ea typeface="微軟正黑體" panose="020B0604030504040204" pitchFamily="34" charset="-120"/>
+                <a:cs typeface="Heiti TC Light"/>
+              </a:rPr>
+              <a:t>或做出的動作</a:t>
+            </a:r>
+            <a:r>
+              <a:rPr kumimoji="1" lang="en-US" altLang="zh-TW" sz="3200" dirty="0">
+                <a:effectLst>
+                  <a:outerShdw blurRad="38100" dist="38100" dir="2700000" algn="tl">
+                    <a:srgbClr val="000000">
+                      <a:alpha val="43137"/>
+                    </a:srgbClr>
+                  </a:outerShdw>
+                </a:effectLst>
+                <a:latin typeface="微軟正黑體" panose="020B0604030504040204" pitchFamily="34" charset="-120"/>
+                <a:ea typeface="微軟正黑體" panose="020B0604030504040204" pitchFamily="34" charset="-120"/>
+                <a:cs typeface="Heiti TC Light"/>
+              </a:rPr>
+              <a:t>)</a:t>
+            </a:r>
+            <a:r>
+              <a:rPr kumimoji="1" lang="zh-TW" altLang="en-US" sz="3200" dirty="0">
+                <a:effectLst>
+                  <a:outerShdw blurRad="38100" dist="38100" dir="2700000" algn="tl">
+                    <a:srgbClr val="000000">
+                      <a:alpha val="43137"/>
+                    </a:srgbClr>
+                  </a:outerShdw>
+                </a:effectLst>
+                <a:latin typeface="微軟正黑體" panose="020B0604030504040204" pitchFamily="34" charset="-120"/>
+                <a:ea typeface="微軟正黑體" panose="020B0604030504040204" pitchFamily="34" charset="-120"/>
+                <a:cs typeface="Heiti TC Light"/>
+              </a:rPr>
+              <a:t>，會傳回伺服器</a:t>
+            </a:r>
+            <a:endParaRPr kumimoji="1" lang="en-US" altLang="zh-TW" sz="3200" dirty="0">
+              <a:effectLst>
+                <a:outerShdw blurRad="38100" dist="38100" dir="2700000" algn="tl">
+                  <a:srgbClr val="000000">
+                    <a:alpha val="43137"/>
+                  </a:srgbClr>
+                </a:outerShdw>
+              </a:effectLst>
+              <a:latin typeface="微軟正黑體" panose="020B0604030504040204" pitchFamily="34" charset="-120"/>
+              <a:ea typeface="微軟正黑體" panose="020B0604030504040204" pitchFamily="34" charset="-120"/>
+              <a:cs typeface="Heiti TC Light"/>
+            </a:endParaRPr>
+          </a:p>
+          <a:p>
+            <a:pPr marL="358775" indent="-358775">
+              <a:buFont typeface="Arial" panose="020B0604020202020204" pitchFamily="34" charset="0"/>
+              <a:buChar char="•"/>
+            </a:pPr>
+            <a:r>
+              <a:rPr kumimoji="1" lang="zh-TW" altLang="en-US" sz="3200" dirty="0">
+                <a:effectLst>
+                  <a:outerShdw blurRad="38100" dist="38100" dir="2700000" algn="tl">
+                    <a:srgbClr val="000000">
+                      <a:alpha val="43137"/>
+                    </a:srgbClr>
+                  </a:outerShdw>
+                </a:effectLst>
+                <a:latin typeface="微軟正黑體" panose="020B0604030504040204" pitchFamily="34" charset="-120"/>
+                <a:ea typeface="微軟正黑體" panose="020B0604030504040204" pitchFamily="34" charset="-120"/>
+                <a:cs typeface="Heiti TC Light"/>
+              </a:rPr>
+              <a:t>伺服器必須對這些資料或動作做處理</a:t>
+            </a:r>
+            <a:endParaRPr kumimoji="1" lang="en-US" altLang="zh-TW" sz="3200" dirty="0">
+              <a:effectLst>
+                <a:outerShdw blurRad="38100" dist="38100" dir="2700000" algn="tl">
+                  <a:srgbClr val="000000">
+                    <a:alpha val="43137"/>
+                  </a:srgbClr>
+                </a:outerShdw>
+              </a:effectLst>
+              <a:latin typeface="微軟正黑體" panose="020B0604030504040204" pitchFamily="34" charset="-120"/>
+              <a:ea typeface="微軟正黑體" panose="020B0604030504040204" pitchFamily="34" charset="-120"/>
+              <a:cs typeface="Heiti TC Light"/>
+            </a:endParaRPr>
+          </a:p>
+          <a:p>
+            <a:pPr marL="358775" indent="-358775">
+              <a:buFont typeface="Arial" panose="020B0604020202020204" pitchFamily="34" charset="0"/>
+              <a:buChar char="•"/>
+            </a:pPr>
+            <a:r>
+              <a:rPr kumimoji="1" lang="zh-TW" altLang="en-US" sz="3200" dirty="0">
+                <a:effectLst>
+                  <a:outerShdw blurRad="38100" dist="38100" dir="2700000" algn="tl">
+                    <a:srgbClr val="000000">
+                      <a:alpha val="43137"/>
+                    </a:srgbClr>
+                  </a:outerShdw>
+                </a:effectLst>
+                <a:latin typeface="微軟正黑體" panose="020B0604030504040204" pitchFamily="34" charset="-120"/>
+                <a:ea typeface="微軟正黑體" panose="020B0604030504040204" pitchFamily="34" charset="-120"/>
+                <a:cs typeface="Heiti TC Light"/>
+              </a:rPr>
+              <a:t>例如「傳回搜尋結果」或是「存入資料庫」或是「刷卡進行購買」。</a:t>
+            </a:r>
+            <a:endParaRPr kumimoji="1" lang="en-US" altLang="zh-TW" sz="3200" dirty="0">
+              <a:effectLst>
+                <a:outerShdw blurRad="38100" dist="38100" dir="2700000" algn="tl">
+                  <a:srgbClr val="000000">
+                    <a:alpha val="43137"/>
+                  </a:srgbClr>
+                </a:outerShdw>
+              </a:effectLst>
+              <a:latin typeface="微軟正黑體" panose="020B0604030504040204" pitchFamily="34" charset="-120"/>
+              <a:ea typeface="微軟正黑體" panose="020B0604030504040204" pitchFamily="34" charset="-120"/>
+              <a:cs typeface="Heiti TC Light"/>
+            </a:endParaRPr>
+          </a:p>
+          <a:p>
+            <a:pPr marL="358775" indent="-358775">
+              <a:buFont typeface="Arial" panose="020B0604020202020204" pitchFamily="34" charset="0"/>
+              <a:buChar char="•"/>
+            </a:pPr>
+            <a:r>
+              <a:rPr kumimoji="1" lang="zh-TW" altLang="en-US" sz="3200" dirty="0">
+                <a:effectLst>
+                  <a:outerShdw blurRad="38100" dist="38100" dir="2700000" algn="tl">
+                    <a:srgbClr val="000000">
+                      <a:alpha val="43137"/>
+                    </a:srgbClr>
+                  </a:outerShdw>
+                </a:effectLst>
+                <a:latin typeface="微軟正黑體" panose="020B0604030504040204" pitchFamily="34" charset="-120"/>
+                <a:ea typeface="微軟正黑體" panose="020B0604030504040204" pitchFamily="34" charset="-120"/>
+                <a:cs typeface="Heiti TC Light"/>
+              </a:rPr>
+              <a:t>這些在「伺服器」上進行的動作，必須有一個後台處理，這個後台的設計，就是使用「後端語言」</a:t>
+            </a:r>
+            <a:endParaRPr kumimoji="1" lang="en-US" altLang="zh-TW" sz="3200" dirty="0">
+              <a:effectLst>
+                <a:outerShdw blurRad="38100" dist="38100" dir="2700000" algn="tl">
+                  <a:srgbClr val="000000">
+                    <a:alpha val="43137"/>
+                  </a:srgbClr>
+                </a:outerShdw>
+              </a:effectLst>
+              <a:latin typeface="微軟正黑體" panose="020B0604030504040204" pitchFamily="34" charset="-120"/>
+              <a:ea typeface="微軟正黑體" panose="020B0604030504040204" pitchFamily="34" charset="-120"/>
+              <a:cs typeface="Heiti TC Light"/>
+            </a:endParaRPr>
+          </a:p>
+        </p:txBody>
+      </p:sp>
+    </p:spTree>
+    <p:extLst>
+      <p:ext uri="{BB962C8B-B14F-4D97-AF65-F5344CB8AC3E}">
+        <p14:creationId xmlns:p14="http://schemas.microsoft.com/office/powerpoint/2010/main" val="558760326"/>
+      </p:ext>
+    </p:extLst>
+  </p:cSld>
+  <p:clrMapOvr>
+    <a:masterClrMapping/>
+  </p:clrMapOvr>
+  <p:transition>
+    <p:fade/>
+  </p:transition>
+</p:sld>
+</file>
+
 <file path=ppt/slides/slide39.xml><?xml version="1.0" encoding="utf-8"?>
 <p:sld xmlns:a="http://schemas.openxmlformats.org/drawingml/2006/main" xmlns:r="http://schemas.openxmlformats.org/officeDocument/2006/relationships" xmlns:p="http://schemas.openxmlformats.org/presentationml/2006/main">
   <p:cSld>
@@ -22035,7 +22140,7 @@
                 <a:latin typeface="Arial" panose="020B0604020202020204" pitchFamily="34" charset="0"/>
                 <a:cs typeface="Arial" panose="020B0604020202020204" pitchFamily="34" charset="0"/>
               </a:rPr>
-              <a:t>3/26/2026</a:t>
+              <a:t>4/16/2026</a:t>
             </a:fld>
             <a:endParaRPr kumimoji="0" lang="en-US" dirty="0">
               <a:latin typeface="Arial" panose="020B0604020202020204" pitchFamily="34" charset="0"/>
@@ -22124,7 +22229,7 @@
                 <a:ea typeface="微軟正黑體" panose="020B0604030504040204" pitchFamily="34" charset="-120"/>
                 <a:cs typeface="Heiti TC Light"/>
               </a:rPr>
-              <a:t>使用者在瀏覽器中填寫的資料</a:t>
+              <a:t>後端語言可為通用語言，如</a:t>
             </a:r>
             <a:r>
               <a:rPr kumimoji="1" lang="en-US" altLang="zh-TW" sz="3200" dirty="0">
@@ -22139,7 +22244,7 @@
                 <a:ea typeface="微軟正黑體" panose="020B0604030504040204" pitchFamily="34" charset="-120"/>
                 <a:cs typeface="Heiti TC Light"/>
               </a:rPr>
-              <a:t>(</a:t>
+              <a:t>Java</a:t>
             </a:r>
             <a:r>
               <a:rPr kumimoji="1" lang="zh-TW" altLang="en-US" sz="3200" dirty="0">
@@ -22154,7 +22259,7 @@
                 <a:ea typeface="微軟正黑體" panose="020B0604030504040204" pitchFamily="34" charset="-120"/>
                 <a:cs typeface="Heiti TC Light"/>
               </a:rPr>
-              <a:t>或做出的動作</a:t>
+              <a:t>、</a:t>
             </a:r>
             <a:r>
               <a:rPr kumimoji="1" lang="en-US" altLang="zh-TW" sz="3200" dirty="0">
@@ -22169,7 +22274,7 @@
                 <a:ea typeface="微軟正黑體" panose="020B0604030504040204" pitchFamily="34" charset="-120"/>
                 <a:cs typeface="Heiti TC Light"/>
               </a:rPr>
-              <a:t>)</a:t>
+              <a:t>C#</a:t>
             </a:r>
             <a:r>
               <a:rPr kumimoji="1" lang="zh-TW" altLang="en-US" sz="3200" dirty="0">
@@ -22184,7 +22289,37 @@
                 <a:ea typeface="微軟正黑體" panose="020B0604030504040204" pitchFamily="34" charset="-120"/>
                 <a:cs typeface="Heiti TC Light"/>
               </a:rPr>
-              <a:t>，會傳回伺服器</a:t>
+              <a:t>、</a:t>
+            </a:r>
+            <a:r>
+              <a:rPr kumimoji="1" lang="en-US" altLang="zh-TW" sz="3200" dirty="0">
+                <a:effectLst>
+                  <a:outerShdw blurRad="38100" dist="38100" dir="2700000" algn="tl">
+                    <a:srgbClr val="000000">
+                      <a:alpha val="43137"/>
+                    </a:srgbClr>
+                  </a:outerShdw>
+                </a:effectLst>
+                <a:latin typeface="微軟正黑體" panose="020B0604030504040204" pitchFamily="34" charset="-120"/>
+                <a:ea typeface="微軟正黑體" panose="020B0604030504040204" pitchFamily="34" charset="-120"/>
+                <a:cs typeface="Heiti TC Light"/>
+              </a:rPr>
+              <a:t>Python</a:t>
+            </a:r>
+            <a:r>
+              <a:rPr kumimoji="1" lang="zh-TW" altLang="en-US" sz="3200" dirty="0">
+                <a:effectLst>
+                  <a:outerShdw blurRad="38100" dist="38100" dir="2700000" algn="tl">
+                    <a:srgbClr val="000000">
+                      <a:alpha val="43137"/>
+                    </a:srgbClr>
+                  </a:outerShdw>
+                </a:effectLst>
+                <a:latin typeface="微軟正黑體" panose="020B0604030504040204" pitchFamily="34" charset="-120"/>
+                <a:ea typeface="微軟正黑體" panose="020B0604030504040204" pitchFamily="34" charset="-120"/>
+                <a:cs typeface="Heiti TC Light"/>
+              </a:rPr>
+              <a:t>等。</a:t>
             </a:r>
             <a:endParaRPr kumimoji="1" lang="en-US" altLang="zh-TW" sz="3200" dirty="0">
               <a:effectLst>
@@ -22217,7 +22352,73 @@
                 <a:ea typeface="微軟正黑體" panose="020B0604030504040204" pitchFamily="34" charset="-120"/>
                 <a:cs typeface="Heiti TC Light"/>
               </a:rPr>
-              <a:t>伺服器必須對這些資料或動作做處理</a:t>
+              <a:t>也有專門用來作為後端的語言如</a:t>
+            </a:r>
+            <a:r>
+              <a:rPr kumimoji="1" lang="en-US" altLang="zh-TW" sz="3200" dirty="0">
+                <a:effectLst>
+                  <a:outerShdw blurRad="38100" dist="38100" dir="2700000" algn="tl">
+                    <a:srgbClr val="000000">
+                      <a:alpha val="43137"/>
+                    </a:srgbClr>
+                  </a:outerShdw>
+                </a:effectLst>
+                <a:latin typeface="微軟正黑體" panose="020B0604030504040204" pitchFamily="34" charset="-120"/>
+                <a:ea typeface="微軟正黑體" panose="020B0604030504040204" pitchFamily="34" charset="-120"/>
+                <a:cs typeface="Heiti TC Light"/>
+              </a:rPr>
+              <a:t>PHP</a:t>
+            </a:r>
+          </a:p>
+          <a:p>
+            <a:pPr marL="358775" indent="-358775">
+              <a:buFont typeface="Arial" panose="020B0604020202020204" pitchFamily="34" charset="0"/>
+              <a:buChar char="•"/>
+            </a:pPr>
+            <a:r>
+              <a:rPr kumimoji="1" lang="zh-TW" altLang="en-US" sz="3200" dirty="0">
+                <a:effectLst>
+                  <a:outerShdw blurRad="38100" dist="38100" dir="2700000" algn="tl">
+                    <a:srgbClr val="000000">
+                      <a:alpha val="43137"/>
+                    </a:srgbClr>
+                  </a:outerShdw>
+                </a:effectLst>
+                <a:latin typeface="微軟正黑體" panose="020B0604030504040204" pitchFamily="34" charset="-120"/>
+                <a:ea typeface="微軟正黑體" panose="020B0604030504040204" pitchFamily="34" charset="-120"/>
+                <a:cs typeface="Heiti TC Light"/>
+              </a:rPr>
+              <a:t>通用語言對於處理</a:t>
+            </a:r>
+            <a:r>
+              <a:rPr kumimoji="1" lang="en-US" altLang="zh-TW" sz="3200" dirty="0">
+                <a:effectLst>
+                  <a:outerShdw blurRad="38100" dist="38100" dir="2700000" algn="tl">
+                    <a:srgbClr val="000000">
+                      <a:alpha val="43137"/>
+                    </a:srgbClr>
+                  </a:outerShdw>
+                </a:effectLst>
+                <a:latin typeface="微軟正黑體" panose="020B0604030504040204" pitchFamily="34" charset="-120"/>
+                <a:ea typeface="微軟正黑體" panose="020B0604030504040204" pitchFamily="34" charset="-120"/>
+                <a:cs typeface="Heiti TC Light"/>
+              </a:rPr>
+              <a:t>HTTP/HTTPS</a:t>
+            </a:r>
+            <a:r>
+              <a:rPr kumimoji="1" lang="zh-TW" altLang="en-US" sz="3200" dirty="0">
+                <a:effectLst>
+                  <a:outerShdw blurRad="38100" dist="38100" dir="2700000" algn="tl">
+                    <a:srgbClr val="000000">
+                      <a:alpha val="43137"/>
+                    </a:srgbClr>
+                  </a:outerShdw>
+                </a:effectLst>
+                <a:latin typeface="微軟正黑體" panose="020B0604030504040204" pitchFamily="34" charset="-120"/>
+                <a:ea typeface="微軟正黑體" panose="020B0604030504040204" pitchFamily="34" charset="-120"/>
+                <a:cs typeface="Heiti TC Light"/>
+              </a:rPr>
+              <a:t>的事務必須重新撰寫類別，非常麻煩</a:t>
             </a:r>
             <a:endParaRPr kumimoji="1" lang="en-US" altLang="zh-TW" sz="3200" dirty="0">
               <a:effectLst>
@@ -22250,7 +22451,88 @@
                 <a:ea typeface="微軟正黑體" panose="020B0604030504040204" pitchFamily="34" charset="-120"/>
                 <a:cs typeface="Heiti TC Light"/>
               </a:rPr>
-              <a:t>例如「傳回搜尋結果」或是「存入資料庫」或是「刷卡進行購買」。</a:t>
+              <a:t>開發出用不同後端語言的</a:t>
+            </a:r>
+            <a:r>
+              <a:rPr kumimoji="1" lang="en-US" altLang="zh-TW" sz="3200" dirty="0">
+                <a:effectLst>
+                  <a:outerShdw blurRad="38100" dist="38100" dir="2700000" algn="tl">
+                    <a:srgbClr val="000000">
+                      <a:alpha val="43137"/>
+                    </a:srgbClr>
+                  </a:outerShdw>
+                </a:effectLst>
+                <a:latin typeface="微軟正黑體" panose="020B0604030504040204" pitchFamily="34" charset="-120"/>
+                <a:ea typeface="微軟正黑體" panose="020B0604030504040204" pitchFamily="34" charset="-120"/>
+                <a:cs typeface="Heiti TC Light"/>
+              </a:rPr>
+              <a:t>HTTP/HTTPS</a:t>
+            </a:r>
+            <a:r>
+              <a:rPr kumimoji="1" lang="zh-TW" altLang="en-US" sz="3200" dirty="0">
+                <a:effectLst>
+                  <a:outerShdw blurRad="38100" dist="38100" dir="2700000" algn="tl">
+                    <a:srgbClr val="000000">
+                      <a:alpha val="43137"/>
+                    </a:srgbClr>
+                  </a:outerShdw>
+                </a:effectLst>
+                <a:latin typeface="微軟正黑體" panose="020B0604030504040204" pitchFamily="34" charset="-120"/>
+                <a:ea typeface="微軟正黑體" panose="020B0604030504040204" pitchFamily="34" charset="-120"/>
+                <a:cs typeface="Heiti TC Light"/>
+              </a:rPr>
+              <a:t>專門的類別，稱為「</a:t>
+            </a:r>
+            <a:r>
+              <a:rPr kumimoji="1" lang="en-US" altLang="zh-TW" sz="3200" dirty="0">
+                <a:solidFill>
+                  <a:srgbClr val="FF0000"/>
+                </a:solidFill>
+                <a:effectLst>
+                  <a:outerShdw blurRad="38100" dist="38100" dir="2700000" algn="tl">
+                    <a:srgbClr val="000000">
+                      <a:alpha val="43137"/>
+                    </a:srgbClr>
+                  </a:outerShdw>
+                </a:effectLst>
+                <a:latin typeface="微軟正黑體" panose="020B0604030504040204" pitchFamily="34" charset="-120"/>
+                <a:ea typeface="微軟正黑體" panose="020B0604030504040204" pitchFamily="34" charset="-120"/>
+                <a:cs typeface="Heiti TC Light"/>
+              </a:rPr>
+              <a:t>Web</a:t>
+            </a:r>
+            <a:r>
+              <a:rPr kumimoji="1" lang="zh-TW" altLang="en-US" sz="3200" dirty="0">
+                <a:solidFill>
+                  <a:srgbClr val="FF0000"/>
+                </a:solidFill>
+                <a:effectLst>
+                  <a:outerShdw blurRad="38100" dist="38100" dir="2700000" algn="tl">
+                    <a:srgbClr val="000000">
+                      <a:alpha val="43137"/>
+                    </a:srgbClr>
+                  </a:outerShdw>
+                </a:effectLst>
+                <a:latin typeface="微軟正黑體" panose="020B0604030504040204" pitchFamily="34" charset="-120"/>
+                <a:ea typeface="微軟正黑體" panose="020B0604030504040204" pitchFamily="34" charset="-120"/>
+                <a:cs typeface="Heiti TC Light"/>
+              </a:rPr>
+              <a:t>框架</a:t>
+            </a:r>
+            <a:r>
+              <a:rPr kumimoji="1" lang="zh-TW" altLang="en-US" sz="3200" dirty="0">
+                <a:effectLst>
+                  <a:outerShdw blurRad="38100" dist="38100" dir="2700000" algn="tl">
+                    <a:srgbClr val="000000">
+                      <a:alpha val="43137"/>
+                    </a:srgbClr>
+                  </a:outerShdw>
+                </a:effectLst>
+                <a:latin typeface="微軟正黑體" panose="020B0604030504040204" pitchFamily="34" charset="-120"/>
+                <a:ea typeface="微軟正黑體" panose="020B0604030504040204" pitchFamily="34" charset="-120"/>
+                <a:cs typeface="Heiti TC Light"/>
+              </a:rPr>
+              <a:t>」</a:t>
             </a:r>
             <a:endParaRPr kumimoji="1" lang="en-US" altLang="zh-TW" sz="3200" dirty="0">
               <a:effectLst>
@@ -22271,6 +22553,21 @@
               <a:buChar char="•"/>
             </a:pPr>
             <a:r>
+              <a:rPr kumimoji="1" lang="en-US" altLang="zh-TW" sz="3200" dirty="0">
+                <a:effectLst>
+                  <a:outerShdw blurRad="38100" dist="38100" dir="2700000" algn="tl">
+                    <a:srgbClr val="000000">
+                      <a:alpha val="43137"/>
+                    </a:srgbClr>
+                  </a:outerShdw>
+                </a:effectLst>
+                <a:latin typeface="微軟正黑體" panose="020B0604030504040204" pitchFamily="34" charset="-120"/>
+                <a:ea typeface="微軟正黑體" panose="020B0604030504040204" pitchFamily="34" charset="-120"/>
+                <a:cs typeface="Heiti TC Light"/>
+              </a:rPr>
+              <a:t>Flask</a:t>
+            </a:r>
+            <a:r>
               <a:rPr kumimoji="1" lang="zh-TW" altLang="en-US" sz="3200" dirty="0">
                 <a:effectLst>
                   <a:outerShdw blurRad="38100" dist="38100" dir="2700000" algn="tl">
@@ -22283,7 +22580,67 @@
                 <a:ea typeface="微軟正黑體" panose="020B0604030504040204" pitchFamily="34" charset="-120"/>
                 <a:cs typeface="Heiti TC Light"/>
               </a:rPr>
-              <a:t>這些在「伺服器」上進行的動作，必須有一個後台處理，這個後台的設計，就是使用「後端語言」</a:t>
+              <a:t>就是針對</a:t>
+            </a:r>
+            <a:r>
+              <a:rPr kumimoji="1" lang="en-US" altLang="zh-TW" sz="3200" dirty="0">
+                <a:effectLst>
+                  <a:outerShdw blurRad="38100" dist="38100" dir="2700000" algn="tl">
+                    <a:srgbClr val="000000">
+                      <a:alpha val="43137"/>
+                    </a:srgbClr>
+                  </a:outerShdw>
+                </a:effectLst>
+                <a:latin typeface="微軟正黑體" panose="020B0604030504040204" pitchFamily="34" charset="-120"/>
+                <a:ea typeface="微軟正黑體" panose="020B0604030504040204" pitchFamily="34" charset="-120"/>
+                <a:cs typeface="Heiti TC Light"/>
+              </a:rPr>
+              <a:t>Python</a:t>
+            </a:r>
+            <a:r>
+              <a:rPr kumimoji="1" lang="zh-TW" altLang="en-US" sz="3200" dirty="0">
+                <a:effectLst>
+                  <a:outerShdw blurRad="38100" dist="38100" dir="2700000" algn="tl">
+                    <a:srgbClr val="000000">
+                      <a:alpha val="43137"/>
+                    </a:srgbClr>
+                  </a:outerShdw>
+                </a:effectLst>
+                <a:latin typeface="微軟正黑體" panose="020B0604030504040204" pitchFamily="34" charset="-120"/>
+                <a:ea typeface="微軟正黑體" panose="020B0604030504040204" pitchFamily="34" charset="-120"/>
+                <a:cs typeface="Heiti TC Light"/>
+              </a:rPr>
+              <a:t>開發的</a:t>
+            </a:r>
+            <a:r>
+              <a:rPr kumimoji="1" lang="en-US" altLang="zh-TW" sz="3200" dirty="0">
+                <a:effectLst>
+                  <a:outerShdw blurRad="38100" dist="38100" dir="2700000" algn="tl">
+                    <a:srgbClr val="000000">
+                      <a:alpha val="43137"/>
+                    </a:srgbClr>
+                  </a:outerShdw>
+                </a:effectLst>
+                <a:latin typeface="微軟正黑體" panose="020B0604030504040204" pitchFamily="34" charset="-120"/>
+                <a:ea typeface="微軟正黑體" panose="020B0604030504040204" pitchFamily="34" charset="-120"/>
+                <a:cs typeface="Heiti TC Light"/>
+              </a:rPr>
+              <a:t>Web</a:t>
+            </a:r>
+            <a:r>
+              <a:rPr kumimoji="1" lang="zh-TW" altLang="en-US" sz="3200" dirty="0">
+                <a:effectLst>
+                  <a:outerShdw blurRad="38100" dist="38100" dir="2700000" algn="tl">
+                    <a:srgbClr val="000000">
+                      <a:alpha val="43137"/>
+                    </a:srgbClr>
+                  </a:outerShdw>
+                </a:effectLst>
+                <a:latin typeface="微軟正黑體" panose="020B0604030504040204" pitchFamily="34" charset="-120"/>
+                <a:ea typeface="微軟正黑體" panose="020B0604030504040204" pitchFamily="34" charset="-120"/>
+                <a:cs typeface="Heiti TC Light"/>
+              </a:rPr>
+              <a:t>框架</a:t>
             </a:r>
             <a:endParaRPr kumimoji="1" lang="en-US" altLang="zh-TW" sz="3200" dirty="0">
               <a:effectLst>
@@ -22303,7 +22660,7 @@
     </p:spTree>
     <p:extLst>
       <p:ext uri="{BB962C8B-B14F-4D97-AF65-F5344CB8AC3E}">
-        <p14:creationId xmlns:p14="http://schemas.microsoft.com/office/powerpoint/2010/main" val="558760326"/>
+        <p14:creationId xmlns:p14="http://schemas.microsoft.com/office/powerpoint/2010/main" val="2558907891"/>
       </p:ext>
     </p:extLst>
   </p:cSld>
@@ -22736,8 +23093,8 @@
         </p:nvSpPr>
         <p:spPr>
           <a:xfrm>
-            <a:off x="2362200" y="228600"/>
-            <a:ext cx="5867400" cy="990600"/>
+            <a:off x="3310053" y="150541"/>
+            <a:ext cx="2934629" cy="990600"/>
           </a:xfrm>
           <a:prstGeom prst="rect">
             <a:avLst/>
@@ -22767,7 +23124,7 @@
               <a:defRPr/>
             </a:pPr>
             <a:r>
-              <a:rPr kumimoji="0" lang="zh-TW" altLang="en-US" sz="4800" b="1" i="0" u="none" strike="noStrike" kern="0" cap="none" spc="0" normalizeH="0" baseline="0" noProof="0" dirty="0">
+              <a:rPr kumimoji="0" lang="en-US" altLang="zh-TW" sz="4800" b="1" i="0" u="none" strike="noStrike" kern="0" cap="none" spc="0" normalizeH="0" baseline="0" noProof="0" dirty="0">
                 <a:ln>
                   <a:noFill/>
                 </a:ln>
@@ -22787,632 +23144,10 @@
                 <a:ea typeface="微軟正黑體" panose="020B0604030504040204" pitchFamily="34" charset="-120"/>
                 <a:cs typeface="+mn-cs"/>
               </a:rPr>
-              <a:t>前端和後端語言</a:t>
-            </a:r>
-          </a:p>
-        </p:txBody>
-      </p:sp>
-      <p:sp>
-        <p:nvSpPr>
-          <p:cNvPr id="3" name="日期版面配置區 2">
-            <a:extLst>
-              <a:ext uri="{FF2B5EF4-FFF2-40B4-BE49-F238E27FC236}">
-                <a16:creationId xmlns:a16="http://schemas.microsoft.com/office/drawing/2014/main" id="{1C536CB5-3C58-6CF1-767E-952B76F12DEE}"/>
-              </a:ext>
-            </a:extLst>
-          </p:cNvPr>
-          <p:cNvSpPr>
-            <a:spLocks noGrp="1"/>
-          </p:cNvSpPr>
-          <p:nvPr>
-            <p:ph type="dt" sz="half" idx="12"/>
-          </p:nvPr>
-        </p:nvSpPr>
-        <p:spPr/>
-        <p:txBody>
-          <a:bodyPr/>
-          <a:lstStyle/>
-          <a:p>
-            <a:fld id="{0B520B05-2240-4566-BE2A-9338980FE8EB}" type="datetime1">
-              <a:rPr kumimoji="0" lang="en-US" altLang="zh-TW" sz="1200" smtClean="0">
-                <a:solidFill>
-                  <a:schemeClr val="tx2"/>
-                </a:solidFill>
-                <a:latin typeface="Arial" panose="020B0604020202020204" pitchFamily="34" charset="0"/>
-                <a:cs typeface="Arial" panose="020B0604020202020204" pitchFamily="34" charset="0"/>
-              </a:rPr>
-              <a:t>3/26/2026</a:t>
-            </a:fld>
-            <a:endParaRPr kumimoji="0" lang="en-US" dirty="0">
-              <a:latin typeface="Arial" panose="020B0604020202020204" pitchFamily="34" charset="0"/>
-              <a:cs typeface="Arial" panose="020B0604020202020204" pitchFamily="34" charset="0"/>
-            </a:endParaRPr>
-          </a:p>
-        </p:txBody>
-      </p:sp>
-      <p:sp>
-        <p:nvSpPr>
-          <p:cNvPr id="7" name="投影片編號版面配置區 6">
-            <a:extLst>
-              <a:ext uri="{FF2B5EF4-FFF2-40B4-BE49-F238E27FC236}">
-                <a16:creationId xmlns:a16="http://schemas.microsoft.com/office/drawing/2014/main" id="{DA316F56-AF12-D872-611F-78AE7ACCBF93}"/>
-              </a:ext>
-            </a:extLst>
-          </p:cNvPr>
-          <p:cNvSpPr>
-            <a:spLocks noGrp="1"/>
-          </p:cNvSpPr>
-          <p:nvPr>
-            <p:ph type="sldNum" sz="quarter" idx="13"/>
-          </p:nvPr>
-        </p:nvSpPr>
-        <p:spPr/>
-        <p:txBody>
-          <a:bodyPr/>
-          <a:lstStyle/>
-          <a:p>
-            <a:pPr algn="r"/>
-            <a:fld id="{F99EC173-99AE-4773-AB25-02E469A13EAE}" type="slidenum">
-              <a:rPr kumimoji="0" lang="en-US" sz="1200" smtClean="0">
-                <a:solidFill>
-                  <a:schemeClr val="tx2"/>
-                </a:solidFill>
-              </a:rPr>
-              <a:pPr algn="r"/>
-              <a:t>40</a:t>
-            </a:fld>
-            <a:endParaRPr kumimoji="0" lang="en-US" dirty="0"/>
-          </a:p>
-        </p:txBody>
-      </p:sp>
-      <p:sp>
-        <p:nvSpPr>
-          <p:cNvPr id="2" name="文字方塊 1">
-            <a:extLst>
-              <a:ext uri="{FF2B5EF4-FFF2-40B4-BE49-F238E27FC236}">
-                <a16:creationId xmlns:a16="http://schemas.microsoft.com/office/drawing/2014/main" id="{54D51629-6478-40B0-266D-C39EAC81C327}"/>
-              </a:ext>
-            </a:extLst>
-          </p:cNvPr>
-          <p:cNvSpPr txBox="1"/>
-          <p:nvPr/>
-        </p:nvSpPr>
-        <p:spPr>
-          <a:xfrm>
-            <a:off x="533400" y="1447800"/>
-            <a:ext cx="8305800" cy="4031873"/>
-          </a:xfrm>
-          <a:prstGeom prst="rect">
-            <a:avLst/>
-          </a:prstGeom>
-          <a:noFill/>
-        </p:spPr>
-        <p:txBody>
-          <a:bodyPr wrap="square" rtlCol="0">
-            <a:spAutoFit/>
-          </a:bodyPr>
-          <a:lstStyle/>
-          <a:p>
-            <a:pPr marL="358775" indent="-358775">
-              <a:buFont typeface="Arial" panose="020B0604020202020204" pitchFamily="34" charset="0"/>
-              <a:buChar char="•"/>
-            </a:pPr>
-            <a:r>
-              <a:rPr kumimoji="1" lang="zh-TW" altLang="en-US" sz="3200" dirty="0">
-                <a:effectLst>
-                  <a:outerShdw blurRad="38100" dist="38100" dir="2700000" algn="tl">
-                    <a:srgbClr val="000000">
-                      <a:alpha val="43137"/>
-                    </a:srgbClr>
-                  </a:outerShdw>
-                </a:effectLst>
-                <a:latin typeface="微軟正黑體" panose="020B0604030504040204" pitchFamily="34" charset="-120"/>
-                <a:ea typeface="微軟正黑體" panose="020B0604030504040204" pitchFamily="34" charset="-120"/>
-                <a:cs typeface="Heiti TC Light"/>
-              </a:rPr>
-              <a:t>後端語言可為通用語言，如</a:t>
-            </a:r>
-            <a:r>
-              <a:rPr kumimoji="1" lang="en-US" altLang="zh-TW" sz="3200" dirty="0">
-                <a:effectLst>
-                  <a:outerShdw blurRad="38100" dist="38100" dir="2700000" algn="tl">
-                    <a:srgbClr val="000000">
-                      <a:alpha val="43137"/>
-                    </a:srgbClr>
-                  </a:outerShdw>
-                </a:effectLst>
-                <a:latin typeface="微軟正黑體" panose="020B0604030504040204" pitchFamily="34" charset="-120"/>
-                <a:ea typeface="微軟正黑體" panose="020B0604030504040204" pitchFamily="34" charset="-120"/>
-                <a:cs typeface="Heiti TC Light"/>
-              </a:rPr>
-              <a:t>Java</a:t>
-            </a:r>
-            <a:r>
-              <a:rPr kumimoji="1" lang="zh-TW" altLang="en-US" sz="3200" dirty="0">
-                <a:effectLst>
-                  <a:outerShdw blurRad="38100" dist="38100" dir="2700000" algn="tl">
-                    <a:srgbClr val="000000">
-                      <a:alpha val="43137"/>
-                    </a:srgbClr>
-                  </a:outerShdw>
-                </a:effectLst>
-                <a:latin typeface="微軟正黑體" panose="020B0604030504040204" pitchFamily="34" charset="-120"/>
-                <a:ea typeface="微軟正黑體" panose="020B0604030504040204" pitchFamily="34" charset="-120"/>
-                <a:cs typeface="Heiti TC Light"/>
-              </a:rPr>
-              <a:t>、</a:t>
-            </a:r>
-            <a:r>
-              <a:rPr kumimoji="1" lang="en-US" altLang="zh-TW" sz="3200" dirty="0">
-                <a:effectLst>
-                  <a:outerShdw blurRad="38100" dist="38100" dir="2700000" algn="tl">
-                    <a:srgbClr val="000000">
-                      <a:alpha val="43137"/>
-                    </a:srgbClr>
-                  </a:outerShdw>
-                </a:effectLst>
-                <a:latin typeface="微軟正黑體" panose="020B0604030504040204" pitchFamily="34" charset="-120"/>
-                <a:ea typeface="微軟正黑體" panose="020B0604030504040204" pitchFamily="34" charset="-120"/>
-                <a:cs typeface="Heiti TC Light"/>
-              </a:rPr>
-              <a:t>C#</a:t>
-            </a:r>
-            <a:r>
-              <a:rPr kumimoji="1" lang="zh-TW" altLang="en-US" sz="3200" dirty="0">
-                <a:effectLst>
-                  <a:outerShdw blurRad="38100" dist="38100" dir="2700000" algn="tl">
-                    <a:srgbClr val="000000">
-                      <a:alpha val="43137"/>
-                    </a:srgbClr>
-                  </a:outerShdw>
-                </a:effectLst>
-                <a:latin typeface="微軟正黑體" panose="020B0604030504040204" pitchFamily="34" charset="-120"/>
-                <a:ea typeface="微軟正黑體" panose="020B0604030504040204" pitchFamily="34" charset="-120"/>
-                <a:cs typeface="Heiti TC Light"/>
-              </a:rPr>
-              <a:t>、</a:t>
-            </a:r>
-            <a:r>
-              <a:rPr kumimoji="1" lang="en-US" altLang="zh-TW" sz="3200" dirty="0">
-                <a:effectLst>
-                  <a:outerShdw blurRad="38100" dist="38100" dir="2700000" algn="tl">
-                    <a:srgbClr val="000000">
-                      <a:alpha val="43137"/>
-                    </a:srgbClr>
-                  </a:outerShdw>
-                </a:effectLst>
-                <a:latin typeface="微軟正黑體" panose="020B0604030504040204" pitchFamily="34" charset="-120"/>
-                <a:ea typeface="微軟正黑體" panose="020B0604030504040204" pitchFamily="34" charset="-120"/>
-                <a:cs typeface="Heiti TC Light"/>
-              </a:rPr>
-              <a:t>Python</a:t>
-            </a:r>
-            <a:r>
-              <a:rPr kumimoji="1" lang="zh-TW" altLang="en-US" sz="3200" dirty="0">
-                <a:effectLst>
-                  <a:outerShdw blurRad="38100" dist="38100" dir="2700000" algn="tl">
-                    <a:srgbClr val="000000">
-                      <a:alpha val="43137"/>
-                    </a:srgbClr>
-                  </a:outerShdw>
-                </a:effectLst>
-                <a:latin typeface="微軟正黑體" panose="020B0604030504040204" pitchFamily="34" charset="-120"/>
-                <a:ea typeface="微軟正黑體" panose="020B0604030504040204" pitchFamily="34" charset="-120"/>
-                <a:cs typeface="Heiti TC Light"/>
-              </a:rPr>
-              <a:t>等。</a:t>
-            </a:r>
-            <a:endParaRPr kumimoji="1" lang="en-US" altLang="zh-TW" sz="3200" dirty="0">
-              <a:effectLst>
-                <a:outerShdw blurRad="38100" dist="38100" dir="2700000" algn="tl">
-                  <a:srgbClr val="000000">
-                    <a:alpha val="43137"/>
-                  </a:srgbClr>
-                </a:outerShdw>
-              </a:effectLst>
-              <a:latin typeface="微軟正黑體" panose="020B0604030504040204" pitchFamily="34" charset="-120"/>
-              <a:ea typeface="微軟正黑體" panose="020B0604030504040204" pitchFamily="34" charset="-120"/>
-              <a:cs typeface="Heiti TC Light"/>
-            </a:endParaRPr>
-          </a:p>
-          <a:p>
-            <a:pPr marL="358775" indent="-358775">
-              <a:buFont typeface="Arial" panose="020B0604020202020204" pitchFamily="34" charset="0"/>
-              <a:buChar char="•"/>
-            </a:pPr>
-            <a:r>
-              <a:rPr kumimoji="1" lang="zh-TW" altLang="en-US" sz="3200" dirty="0">
-                <a:effectLst>
-                  <a:outerShdw blurRad="38100" dist="38100" dir="2700000" algn="tl">
-                    <a:srgbClr val="000000">
-                      <a:alpha val="43137"/>
-                    </a:srgbClr>
-                  </a:outerShdw>
-                </a:effectLst>
-                <a:latin typeface="微軟正黑體" panose="020B0604030504040204" pitchFamily="34" charset="-120"/>
-                <a:ea typeface="微軟正黑體" panose="020B0604030504040204" pitchFamily="34" charset="-120"/>
-                <a:cs typeface="Heiti TC Light"/>
-              </a:rPr>
-              <a:t>也有專門用來作為後端的語言如</a:t>
-            </a:r>
-            <a:r>
-              <a:rPr kumimoji="1" lang="en-US" altLang="zh-TW" sz="3200" dirty="0">
-                <a:effectLst>
-                  <a:outerShdw blurRad="38100" dist="38100" dir="2700000" algn="tl">
-                    <a:srgbClr val="000000">
-                      <a:alpha val="43137"/>
-                    </a:srgbClr>
-                  </a:outerShdw>
-                </a:effectLst>
-                <a:latin typeface="微軟正黑體" panose="020B0604030504040204" pitchFamily="34" charset="-120"/>
-                <a:ea typeface="微軟正黑體" panose="020B0604030504040204" pitchFamily="34" charset="-120"/>
-                <a:cs typeface="Heiti TC Light"/>
-              </a:rPr>
-              <a:t>PHP</a:t>
-            </a:r>
-          </a:p>
-          <a:p>
-            <a:pPr marL="358775" indent="-358775">
-              <a:buFont typeface="Arial" panose="020B0604020202020204" pitchFamily="34" charset="0"/>
-              <a:buChar char="•"/>
-            </a:pPr>
-            <a:r>
-              <a:rPr kumimoji="1" lang="zh-TW" altLang="en-US" sz="3200" dirty="0">
-                <a:effectLst>
-                  <a:outerShdw blurRad="38100" dist="38100" dir="2700000" algn="tl">
-                    <a:srgbClr val="000000">
-                      <a:alpha val="43137"/>
-                    </a:srgbClr>
-                  </a:outerShdw>
-                </a:effectLst>
-                <a:latin typeface="微軟正黑體" panose="020B0604030504040204" pitchFamily="34" charset="-120"/>
-                <a:ea typeface="微軟正黑體" panose="020B0604030504040204" pitchFamily="34" charset="-120"/>
-                <a:cs typeface="Heiti TC Light"/>
-              </a:rPr>
-              <a:t>通用語言對於處理</a:t>
-            </a:r>
-            <a:r>
-              <a:rPr kumimoji="1" lang="en-US" altLang="zh-TW" sz="3200" dirty="0">
-                <a:effectLst>
-                  <a:outerShdw blurRad="38100" dist="38100" dir="2700000" algn="tl">
-                    <a:srgbClr val="000000">
-                      <a:alpha val="43137"/>
-                    </a:srgbClr>
-                  </a:outerShdw>
-                </a:effectLst>
-                <a:latin typeface="微軟正黑體" panose="020B0604030504040204" pitchFamily="34" charset="-120"/>
-                <a:ea typeface="微軟正黑體" panose="020B0604030504040204" pitchFamily="34" charset="-120"/>
-                <a:cs typeface="Heiti TC Light"/>
-              </a:rPr>
-              <a:t>HTTP/HTTPS</a:t>
-            </a:r>
-            <a:r>
-              <a:rPr kumimoji="1" lang="zh-TW" altLang="en-US" sz="3200" dirty="0">
-                <a:effectLst>
-                  <a:outerShdw blurRad="38100" dist="38100" dir="2700000" algn="tl">
-                    <a:srgbClr val="000000">
-                      <a:alpha val="43137"/>
-                    </a:srgbClr>
-                  </a:outerShdw>
-                </a:effectLst>
-                <a:latin typeface="微軟正黑體" panose="020B0604030504040204" pitchFamily="34" charset="-120"/>
-                <a:ea typeface="微軟正黑體" panose="020B0604030504040204" pitchFamily="34" charset="-120"/>
-                <a:cs typeface="Heiti TC Light"/>
-              </a:rPr>
-              <a:t>的事務必須重新撰寫類別，非常麻煩</a:t>
-            </a:r>
-            <a:endParaRPr kumimoji="1" lang="en-US" altLang="zh-TW" sz="3200" dirty="0">
-              <a:effectLst>
-                <a:outerShdw blurRad="38100" dist="38100" dir="2700000" algn="tl">
-                  <a:srgbClr val="000000">
-                    <a:alpha val="43137"/>
-                  </a:srgbClr>
-                </a:outerShdw>
-              </a:effectLst>
-              <a:latin typeface="微軟正黑體" panose="020B0604030504040204" pitchFamily="34" charset="-120"/>
-              <a:ea typeface="微軟正黑體" panose="020B0604030504040204" pitchFamily="34" charset="-120"/>
-              <a:cs typeface="Heiti TC Light"/>
-            </a:endParaRPr>
-          </a:p>
-          <a:p>
-            <a:pPr marL="358775" indent="-358775">
-              <a:buFont typeface="Arial" panose="020B0604020202020204" pitchFamily="34" charset="0"/>
-              <a:buChar char="•"/>
-            </a:pPr>
-            <a:r>
-              <a:rPr kumimoji="1" lang="zh-TW" altLang="en-US" sz="3200" dirty="0">
-                <a:effectLst>
-                  <a:outerShdw blurRad="38100" dist="38100" dir="2700000" algn="tl">
-                    <a:srgbClr val="000000">
-                      <a:alpha val="43137"/>
-                    </a:srgbClr>
-                  </a:outerShdw>
-                </a:effectLst>
-                <a:latin typeface="微軟正黑體" panose="020B0604030504040204" pitchFamily="34" charset="-120"/>
-                <a:ea typeface="微軟正黑體" panose="020B0604030504040204" pitchFamily="34" charset="-120"/>
-                <a:cs typeface="Heiti TC Light"/>
-              </a:rPr>
-              <a:t>開發出用不同後端語言的</a:t>
-            </a:r>
-            <a:r>
-              <a:rPr kumimoji="1" lang="en-US" altLang="zh-TW" sz="3200" dirty="0">
-                <a:effectLst>
-                  <a:outerShdw blurRad="38100" dist="38100" dir="2700000" algn="tl">
-                    <a:srgbClr val="000000">
-                      <a:alpha val="43137"/>
-                    </a:srgbClr>
-                  </a:outerShdw>
-                </a:effectLst>
-                <a:latin typeface="微軟正黑體" panose="020B0604030504040204" pitchFamily="34" charset="-120"/>
-                <a:ea typeface="微軟正黑體" panose="020B0604030504040204" pitchFamily="34" charset="-120"/>
-                <a:cs typeface="Heiti TC Light"/>
-              </a:rPr>
-              <a:t>HTTP/HTTPS</a:t>
-            </a:r>
-            <a:r>
-              <a:rPr kumimoji="1" lang="zh-TW" altLang="en-US" sz="3200" dirty="0">
-                <a:effectLst>
-                  <a:outerShdw blurRad="38100" dist="38100" dir="2700000" algn="tl">
-                    <a:srgbClr val="000000">
-                      <a:alpha val="43137"/>
-                    </a:srgbClr>
-                  </a:outerShdw>
-                </a:effectLst>
-                <a:latin typeface="微軟正黑體" panose="020B0604030504040204" pitchFamily="34" charset="-120"/>
-                <a:ea typeface="微軟正黑體" panose="020B0604030504040204" pitchFamily="34" charset="-120"/>
-                <a:cs typeface="Heiti TC Light"/>
-              </a:rPr>
-              <a:t>專門的類別，稱為「</a:t>
-            </a:r>
-            <a:r>
-              <a:rPr kumimoji="1" lang="en-US" altLang="zh-TW" sz="3200" dirty="0">
-                <a:solidFill>
-                  <a:srgbClr val="FF0000"/>
-                </a:solidFill>
-                <a:effectLst>
-                  <a:outerShdw blurRad="38100" dist="38100" dir="2700000" algn="tl">
-                    <a:srgbClr val="000000">
-                      <a:alpha val="43137"/>
-                    </a:srgbClr>
-                  </a:outerShdw>
-                </a:effectLst>
-                <a:latin typeface="微軟正黑體" panose="020B0604030504040204" pitchFamily="34" charset="-120"/>
-                <a:ea typeface="微軟正黑體" panose="020B0604030504040204" pitchFamily="34" charset="-120"/>
-                <a:cs typeface="Heiti TC Light"/>
-              </a:rPr>
-              <a:t>Web</a:t>
-            </a:r>
-            <a:r>
-              <a:rPr kumimoji="1" lang="zh-TW" altLang="en-US" sz="3200" dirty="0">
-                <a:solidFill>
-                  <a:srgbClr val="FF0000"/>
-                </a:solidFill>
-                <a:effectLst>
-                  <a:outerShdw blurRad="38100" dist="38100" dir="2700000" algn="tl">
-                    <a:srgbClr val="000000">
-                      <a:alpha val="43137"/>
-                    </a:srgbClr>
-                  </a:outerShdw>
-                </a:effectLst>
-                <a:latin typeface="微軟正黑體" panose="020B0604030504040204" pitchFamily="34" charset="-120"/>
-                <a:ea typeface="微軟正黑體" panose="020B0604030504040204" pitchFamily="34" charset="-120"/>
-                <a:cs typeface="Heiti TC Light"/>
-              </a:rPr>
-              <a:t>框架</a:t>
-            </a:r>
-            <a:r>
-              <a:rPr kumimoji="1" lang="zh-TW" altLang="en-US" sz="3200" dirty="0">
-                <a:effectLst>
-                  <a:outerShdw blurRad="38100" dist="38100" dir="2700000" algn="tl">
-                    <a:srgbClr val="000000">
-                      <a:alpha val="43137"/>
-                    </a:srgbClr>
-                  </a:outerShdw>
-                </a:effectLst>
-                <a:latin typeface="微軟正黑體" panose="020B0604030504040204" pitchFamily="34" charset="-120"/>
-                <a:ea typeface="微軟正黑體" panose="020B0604030504040204" pitchFamily="34" charset="-120"/>
-                <a:cs typeface="Heiti TC Light"/>
-              </a:rPr>
-              <a:t>」</a:t>
-            </a:r>
-            <a:endParaRPr kumimoji="1" lang="en-US" altLang="zh-TW" sz="3200" dirty="0">
-              <a:effectLst>
-                <a:outerShdw blurRad="38100" dist="38100" dir="2700000" algn="tl">
-                  <a:srgbClr val="000000">
-                    <a:alpha val="43137"/>
-                  </a:srgbClr>
-                </a:outerShdw>
-              </a:effectLst>
-              <a:latin typeface="微軟正黑體" panose="020B0604030504040204" pitchFamily="34" charset="-120"/>
-              <a:ea typeface="微軟正黑體" panose="020B0604030504040204" pitchFamily="34" charset="-120"/>
-              <a:cs typeface="Heiti TC Light"/>
-            </a:endParaRPr>
-          </a:p>
-          <a:p>
-            <a:pPr marL="358775" indent="-358775">
-              <a:buFont typeface="Arial" panose="020B0604020202020204" pitchFamily="34" charset="0"/>
-              <a:buChar char="•"/>
-            </a:pPr>
-            <a:r>
-              <a:rPr kumimoji="1" lang="en-US" altLang="zh-TW" sz="3200" dirty="0">
-                <a:effectLst>
-                  <a:outerShdw blurRad="38100" dist="38100" dir="2700000" algn="tl">
-                    <a:srgbClr val="000000">
-                      <a:alpha val="43137"/>
-                    </a:srgbClr>
-                  </a:outerShdw>
-                </a:effectLst>
-                <a:latin typeface="微軟正黑體" panose="020B0604030504040204" pitchFamily="34" charset="-120"/>
-                <a:ea typeface="微軟正黑體" panose="020B0604030504040204" pitchFamily="34" charset="-120"/>
-                <a:cs typeface="Heiti TC Light"/>
-              </a:rPr>
               <a:t>Flask</a:t>
             </a:r>
             <a:r>
-              <a:rPr kumimoji="1" lang="zh-TW" altLang="en-US" sz="3200" dirty="0">
-                <a:effectLst>
-                  <a:outerShdw blurRad="38100" dist="38100" dir="2700000" algn="tl">
-                    <a:srgbClr val="000000">
-                      <a:alpha val="43137"/>
-                    </a:srgbClr>
-                  </a:outerShdw>
-                </a:effectLst>
-                <a:latin typeface="微軟正黑體" panose="020B0604030504040204" pitchFamily="34" charset="-120"/>
-                <a:ea typeface="微軟正黑體" panose="020B0604030504040204" pitchFamily="34" charset="-120"/>
-                <a:cs typeface="Heiti TC Light"/>
-              </a:rPr>
-              <a:t>就是針對</a:t>
-            </a:r>
-            <a:r>
-              <a:rPr kumimoji="1" lang="en-US" altLang="zh-TW" sz="3200" dirty="0">
-                <a:effectLst>
-                  <a:outerShdw blurRad="38100" dist="38100" dir="2700000" algn="tl">
-                    <a:srgbClr val="000000">
-                      <a:alpha val="43137"/>
-                    </a:srgbClr>
-                  </a:outerShdw>
-                </a:effectLst>
-                <a:latin typeface="微軟正黑體" panose="020B0604030504040204" pitchFamily="34" charset="-120"/>
-                <a:ea typeface="微軟正黑體" panose="020B0604030504040204" pitchFamily="34" charset="-120"/>
-                <a:cs typeface="Heiti TC Light"/>
-              </a:rPr>
-              <a:t>Python</a:t>
-            </a:r>
-            <a:r>
-              <a:rPr kumimoji="1" lang="zh-TW" altLang="en-US" sz="3200" dirty="0">
-                <a:effectLst>
-                  <a:outerShdw blurRad="38100" dist="38100" dir="2700000" algn="tl">
-                    <a:srgbClr val="000000">
-                      <a:alpha val="43137"/>
-                    </a:srgbClr>
-                  </a:outerShdw>
-                </a:effectLst>
-                <a:latin typeface="微軟正黑體" panose="020B0604030504040204" pitchFamily="34" charset="-120"/>
-                <a:ea typeface="微軟正黑體" panose="020B0604030504040204" pitchFamily="34" charset="-120"/>
-                <a:cs typeface="Heiti TC Light"/>
-              </a:rPr>
-              <a:t>開發的</a:t>
-            </a:r>
-            <a:r>
-              <a:rPr kumimoji="1" lang="en-US" altLang="zh-TW" sz="3200" dirty="0">
-                <a:effectLst>
-                  <a:outerShdw blurRad="38100" dist="38100" dir="2700000" algn="tl">
-                    <a:srgbClr val="000000">
-                      <a:alpha val="43137"/>
-                    </a:srgbClr>
-                  </a:outerShdw>
-                </a:effectLst>
-                <a:latin typeface="微軟正黑體" panose="020B0604030504040204" pitchFamily="34" charset="-120"/>
-                <a:ea typeface="微軟正黑體" panose="020B0604030504040204" pitchFamily="34" charset="-120"/>
-                <a:cs typeface="Heiti TC Light"/>
-              </a:rPr>
-              <a:t>Web</a:t>
-            </a:r>
-            <a:r>
-              <a:rPr kumimoji="1" lang="zh-TW" altLang="en-US" sz="3200" dirty="0">
-                <a:effectLst>
-                  <a:outerShdw blurRad="38100" dist="38100" dir="2700000" algn="tl">
-                    <a:srgbClr val="000000">
-                      <a:alpha val="43137"/>
-                    </a:srgbClr>
-                  </a:outerShdw>
-                </a:effectLst>
-                <a:latin typeface="微軟正黑體" panose="020B0604030504040204" pitchFamily="34" charset="-120"/>
-                <a:ea typeface="微軟正黑體" panose="020B0604030504040204" pitchFamily="34" charset="-120"/>
-                <a:cs typeface="Heiti TC Light"/>
-              </a:rPr>
-              <a:t>框架</a:t>
-            </a:r>
-            <a:endParaRPr kumimoji="1" lang="en-US" altLang="zh-TW" sz="3200" dirty="0">
-              <a:effectLst>
-                <a:outerShdw blurRad="38100" dist="38100" dir="2700000" algn="tl">
-                  <a:srgbClr val="000000">
-                    <a:alpha val="43137"/>
-                  </a:srgbClr>
-                </a:outerShdw>
-              </a:effectLst>
-              <a:latin typeface="微軟正黑體" panose="020B0604030504040204" pitchFamily="34" charset="-120"/>
-              <a:ea typeface="微軟正黑體" panose="020B0604030504040204" pitchFamily="34" charset="-120"/>
-              <a:cs typeface="Heiti TC Light"/>
-            </a:endParaRPr>
-          </a:p>
-        </p:txBody>
-      </p:sp>
-    </p:spTree>
-    <p:extLst>
-      <p:ext uri="{BB962C8B-B14F-4D97-AF65-F5344CB8AC3E}">
-        <p14:creationId xmlns:p14="http://schemas.microsoft.com/office/powerpoint/2010/main" val="2558907891"/>
-      </p:ext>
-    </p:extLst>
-  </p:cSld>
-  <p:clrMapOvr>
-    <a:masterClrMapping/>
-  </p:clrMapOvr>
-  <p:transition>
-    <p:fade/>
-  </p:transition>
-</p:sld>
-</file>
-
-<file path=ppt/slides/slide41.xml><?xml version="1.0" encoding="utf-8"?>
-<p:sld xmlns:a="http://schemas.openxmlformats.org/drawingml/2006/main" xmlns:r="http://schemas.openxmlformats.org/officeDocument/2006/relationships" xmlns:p="http://schemas.openxmlformats.org/presentationml/2006/main">
-  <p:cSld>
-    <p:spTree>
-      <p:nvGrpSpPr>
-        <p:cNvPr id="1" name=""/>
-        <p:cNvGrpSpPr/>
-        <p:nvPr/>
-      </p:nvGrpSpPr>
-      <p:grpSpPr>
-        <a:xfrm>
-          <a:off x="0" y="0"/>
-          <a:ext cx="0" cy="0"/>
-          <a:chOff x="0" y="0"/>
-          <a:chExt cx="0" cy="0"/>
-        </a:xfrm>
-      </p:grpSpPr>
-      <p:sp>
-        <p:nvSpPr>
-          <p:cNvPr id="4" name="文字版面配置區 2"/>
-          <p:cNvSpPr txBox="1">
-            <a:spLocks/>
-          </p:cNvSpPr>
-          <p:nvPr/>
-        </p:nvSpPr>
-        <p:spPr>
-          <a:xfrm>
-            <a:off x="3310053" y="150541"/>
-            <a:ext cx="2934629" cy="990600"/>
-          </a:xfrm>
-          <a:prstGeom prst="rect">
-            <a:avLst/>
-          </a:prstGeom>
-        </p:spPr>
-        <p:txBody>
-          <a:bodyPr tIns="91440" bIns="91440" anchor="b" anchorCtr="0">
-            <a:noAutofit/>
-          </a:bodyPr>
-          <a:lstStyle/>
-          <a:p>
-            <a:pPr marL="0" marR="0" lvl="0" indent="0" algn="just" defTabSz="914400" rtl="0" eaLnBrk="1" fontAlgn="auto" latinLnBrk="0" hangingPunct="1">
-              <a:lnSpc>
-                <a:spcPct val="100000"/>
-              </a:lnSpc>
-              <a:spcBef>
-                <a:spcPct val="20000"/>
-              </a:spcBef>
-              <a:spcAft>
-                <a:spcPts val="0"/>
-              </a:spcAft>
-              <a:buClrTx/>
-              <a:buSzTx/>
-              <a:buFontTx/>
-              <a:buNone/>
-              <a:tabLst/>
-              <a:defRPr/>
-            </a:pPr>
-            <a:r>
-              <a:rPr kumimoji="0" lang="en-US" altLang="zh-TW" sz="4800" b="1" i="0" u="none" strike="noStrike" kern="0" cap="none" spc="0" normalizeH="0" baseline="0" noProof="0" dirty="0">
+              <a:rPr kumimoji="0" lang="zh-TW" altLang="en-US" sz="4800" b="1" i="0" u="none" strike="noStrike" kern="0" cap="none" spc="0" normalizeH="0" baseline="0" noProof="0" dirty="0">
                 <a:ln>
                   <a:noFill/>
                 </a:ln>
@@ -23432,29 +23167,6 @@
                 <a:ea typeface="微軟正黑體" panose="020B0604030504040204" pitchFamily="34" charset="-120"/>
                 <a:cs typeface="+mn-cs"/>
               </a:rPr>
-              <a:t>Flask</a:t>
-            </a:r>
-            <a:r>
-              <a:rPr kumimoji="0" lang="zh-TW" altLang="en-US" sz="4800" b="1" i="0" u="none" strike="noStrike" kern="0" cap="none" spc="0" normalizeH="0" baseline="0" noProof="0" dirty="0">
-                <a:ln>
-                  <a:noFill/>
-                </a:ln>
-                <a:solidFill>
-                  <a:srgbClr val="00B0F0"/>
-                </a:solidFill>
-                <a:effectLst>
-                  <a:outerShdw blurRad="38100" dist="38100" dir="2700000" algn="tl">
-                    <a:srgbClr val="000000">
-                      <a:alpha val="43137"/>
-                    </a:srgbClr>
-                  </a:outerShdw>
-                </a:effectLst>
-                <a:uLnTx/>
-                <a:uFillTx/>
-                <a:latin typeface="微軟正黑體" panose="020B0604030504040204" pitchFamily="34" charset="-120"/>
-                <a:ea typeface="微軟正黑體" panose="020B0604030504040204" pitchFamily="34" charset="-120"/>
-                <a:cs typeface="+mn-cs"/>
-              </a:rPr>
               <a:t>介紹</a:t>
             </a:r>
           </a:p>
@@ -23489,7 +23201,7 @@
                 <a:latin typeface="Arial" panose="020B0604020202020204" pitchFamily="34" charset="0"/>
                 <a:cs typeface="Arial" panose="020B0604020202020204" pitchFamily="34" charset="0"/>
               </a:rPr>
-              <a:t>3/26/2026</a:t>
+              <a:t>4/16/2026</a:t>
             </a:fld>
             <a:endParaRPr kumimoji="0" lang="en-US" dirty="0">
               <a:latin typeface="Arial" panose="020B0604020202020204" pitchFamily="34" charset="0"/>
@@ -23527,7 +23239,7 @@
                 </a:solidFill>
               </a:rPr>
               <a:pPr algn="r"/>
-              <a:t>41</a:t>
+              <a:t>40</a:t>
             </a:fld>
             <a:endParaRPr kumimoji="0" lang="en-US" dirty="0"/>
           </a:p>
@@ -23842,7 +23554,7 @@
 </p:sld>
 </file>
 
-<file path=ppt/slides/slide42.xml><?xml version="1.0" encoding="utf-8"?>
+<file path=ppt/slides/slide41.xml><?xml version="1.0" encoding="utf-8"?>
 <p:sld xmlns:a="http://schemas.openxmlformats.org/drawingml/2006/main" xmlns:r="http://schemas.openxmlformats.org/officeDocument/2006/relationships" xmlns:p="http://schemas.openxmlformats.org/presentationml/2006/main">
   <p:cSld>
     <p:spTree>
@@ -23905,7 +23617,7 @@
 </p:sld>
 </file>
 
-<file path=ppt/slides/slide43.xml><?xml version="1.0" encoding="utf-8"?>
+<file path=ppt/slides/slide42.xml><?xml version="1.0" encoding="utf-8"?>
 <p:sld xmlns:a="http://schemas.openxmlformats.org/drawingml/2006/main" xmlns:r="http://schemas.openxmlformats.org/officeDocument/2006/relationships" xmlns:p="http://schemas.openxmlformats.org/presentationml/2006/main">
   <p:cSld>
     <p:spTree>
@@ -23968,7 +23680,7 @@
 </p:sld>
 </file>
 
-<file path=ppt/slides/slide44.xml><?xml version="1.0" encoding="utf-8"?>
+<file path=ppt/slides/slide43.xml><?xml version="1.0" encoding="utf-8"?>
 <p:sld xmlns:a="http://schemas.openxmlformats.org/drawingml/2006/main" xmlns:r="http://schemas.openxmlformats.org/officeDocument/2006/relationships" xmlns:p="http://schemas.openxmlformats.org/presentationml/2006/main">
   <p:cSld>
     <p:spTree>

</xml_diff>